<commit_message>
Updted the Report and Folder structue for submission
</commit_message>
<xml_diff>
--- a/slides_fully_editable.pptx
+++ b/slides_fully_editable.pptx
@@ -5,19 +5,19 @@
     <p:sldMasterId id="2147483648" r:id="rId1"/>
   </p:sldMasterIdLst>
   <p:sldIdLst>
-    <p:sldId id="256" r:id="rId7"/>
-    <p:sldId id="257" r:id="rId8"/>
-    <p:sldId id="258" r:id="rId9"/>
-    <p:sldId id="259" r:id="rId10"/>
-    <p:sldId id="260" r:id="rId11"/>
-    <p:sldId id="261" r:id="rId12"/>
-    <p:sldId id="262" r:id="rId13"/>
-    <p:sldId id="263" r:id="rId14"/>
-    <p:sldId id="264" r:id="rId15"/>
-    <p:sldId id="265" r:id="rId16"/>
-    <p:sldId id="266" r:id="rId17"/>
+    <p:sldId id="256" r:id="rId2"/>
+    <p:sldId id="257" r:id="rId3"/>
+    <p:sldId id="258" r:id="rId4"/>
+    <p:sldId id="259" r:id="rId5"/>
+    <p:sldId id="260" r:id="rId6"/>
+    <p:sldId id="261" r:id="rId7"/>
+    <p:sldId id="262" r:id="rId8"/>
+    <p:sldId id="263" r:id="rId9"/>
+    <p:sldId id="264" r:id="rId10"/>
+    <p:sldId id="265" r:id="rId11"/>
+    <p:sldId id="266" r:id="rId12"/>
   </p:sldIdLst>
-  <p:sldSz cx="12191999" cy="6858000" type="screen4x3"/>
+  <p:sldSz cx="12192000" cy="6858000"/>
   <p:notesSz cx="6858000" cy="9144000"/>
   <p:defaultTextStyle>
     <a:defPPr>
@@ -114,6 +114,22 @@
       </a:defRPr>
     </a:lvl9pPr>
   </p:defaultTextStyle>
+  <p:extLst>
+    <p:ext uri="{EFAFB233-063F-42B5-8137-9DF3F51BA10A}">
+      <p15:sldGuideLst xmlns:p15="http://schemas.microsoft.com/office/powerpoint/2012/main">
+        <p15:guide id="1" orient="horz" pos="2160">
+          <p15:clr>
+            <a:srgbClr val="A4A3A4"/>
+          </p15:clr>
+        </p15:guide>
+        <p15:guide id="2" pos="2880">
+          <p15:clr>
+            <a:srgbClr val="A4A3A4"/>
+          </p15:clr>
+        </p15:guide>
+      </p15:sldGuideLst>
+    </p:ext>
+  </p:extLst>
 </p:presentation>
 </file>
 
@@ -155,10 +171,9 @@
           <a:lstStyle/>
           <a:p>
             <a:r>
-              <a:rPr lang="en-US" smtClean="0"/>
+              <a:rPr lang="en-US"/>
               <a:t>Click to edit Master title style</a:t>
             </a:r>
-            <a:endParaRPr lang="en-US"/>
           </a:p>
         </p:txBody>
       </p:sp>
@@ -274,10 +289,9 @@
           </a:lstStyle>
           <a:p>
             <a:r>
-              <a:rPr lang="en-US" smtClean="0"/>
+              <a:rPr lang="en-US"/>
               <a:t>Click to edit Master subtitle style</a:t>
             </a:r>
-            <a:endParaRPr lang="en-US"/>
           </a:p>
         </p:txBody>
       </p:sp>
@@ -298,7 +312,7 @@
           <a:p>
             <a:fld id="{5BCAD085-E8A6-8845-BD4E-CB4CCA059FC4}" type="datetimeFigureOut">
               <a:rPr lang="en-US" smtClean="0"/>
-              <a:t>1/27/13</a:t>
+              <a:t>5/25/2026</a:t>
             </a:fld>
             <a:endParaRPr lang="en-US"/>
           </a:p>
@@ -392,10 +406,9 @@
           <a:lstStyle/>
           <a:p>
             <a:r>
-              <a:rPr lang="en-US" smtClean="0"/>
+              <a:rPr lang="en-US"/>
               <a:t>Click to edit Master title style</a:t>
             </a:r>
-            <a:endParaRPr lang="en-US"/>
           </a:p>
         </p:txBody>
       </p:sp>
@@ -416,38 +429,37 @@
           <a:p>
             <a:pPr lvl="0"/>
             <a:r>
-              <a:rPr lang="en-US" smtClean="0"/>
+              <a:rPr lang="en-US"/>
               <a:t>Click to edit Master text styles</a:t>
             </a:r>
           </a:p>
           <a:p>
             <a:pPr lvl="1"/>
             <a:r>
-              <a:rPr lang="en-US" smtClean="0"/>
+              <a:rPr lang="en-US"/>
               <a:t>Second level</a:t>
             </a:r>
           </a:p>
           <a:p>
             <a:pPr lvl="2"/>
             <a:r>
-              <a:rPr lang="en-US" smtClean="0"/>
+              <a:rPr lang="en-US"/>
               <a:t>Third level</a:t>
             </a:r>
           </a:p>
           <a:p>
             <a:pPr lvl="3"/>
             <a:r>
-              <a:rPr lang="en-US" smtClean="0"/>
+              <a:rPr lang="en-US"/>
               <a:t>Fourth level</a:t>
             </a:r>
           </a:p>
           <a:p>
             <a:pPr lvl="4"/>
             <a:r>
-              <a:rPr lang="en-US" smtClean="0"/>
+              <a:rPr lang="en-US"/>
               <a:t>Fifth level</a:t>
             </a:r>
-            <a:endParaRPr lang="en-US"/>
           </a:p>
         </p:txBody>
       </p:sp>
@@ -468,7 +480,7 @@
           <a:p>
             <a:fld id="{5BCAD085-E8A6-8845-BD4E-CB4CCA059FC4}" type="datetimeFigureOut">
               <a:rPr lang="en-US" smtClean="0"/>
-              <a:t>1/27/13</a:t>
+              <a:t>5/25/2026</a:t>
             </a:fld>
             <a:endParaRPr lang="en-US"/>
           </a:p>
@@ -567,10 +579,9 @@
           <a:lstStyle/>
           <a:p>
             <a:r>
-              <a:rPr lang="en-US" smtClean="0"/>
+              <a:rPr lang="en-US"/>
               <a:t>Click to edit Master title style</a:t>
             </a:r>
-            <a:endParaRPr lang="en-US"/>
           </a:p>
         </p:txBody>
       </p:sp>
@@ -596,38 +607,37 @@
           <a:p>
             <a:pPr lvl="0"/>
             <a:r>
-              <a:rPr lang="en-US" smtClean="0"/>
+              <a:rPr lang="en-US"/>
               <a:t>Click to edit Master text styles</a:t>
             </a:r>
           </a:p>
           <a:p>
             <a:pPr lvl="1"/>
             <a:r>
-              <a:rPr lang="en-US" smtClean="0"/>
+              <a:rPr lang="en-US"/>
               <a:t>Second level</a:t>
             </a:r>
           </a:p>
           <a:p>
             <a:pPr lvl="2"/>
             <a:r>
-              <a:rPr lang="en-US" smtClean="0"/>
+              <a:rPr lang="en-US"/>
               <a:t>Third level</a:t>
             </a:r>
           </a:p>
           <a:p>
             <a:pPr lvl="3"/>
             <a:r>
-              <a:rPr lang="en-US" smtClean="0"/>
+              <a:rPr lang="en-US"/>
               <a:t>Fourth level</a:t>
             </a:r>
           </a:p>
           <a:p>
             <a:pPr lvl="4"/>
             <a:r>
-              <a:rPr lang="en-US" smtClean="0"/>
+              <a:rPr lang="en-US"/>
               <a:t>Fifth level</a:t>
             </a:r>
-            <a:endParaRPr lang="en-US"/>
           </a:p>
         </p:txBody>
       </p:sp>
@@ -648,7 +658,7 @@
           <a:p>
             <a:fld id="{5BCAD085-E8A6-8845-BD4E-CB4CCA059FC4}" type="datetimeFigureOut">
               <a:rPr lang="en-US" smtClean="0"/>
-              <a:t>1/27/13</a:t>
+              <a:t>5/25/2026</a:t>
             </a:fld>
             <a:endParaRPr lang="en-US"/>
           </a:p>
@@ -742,10 +752,9 @@
           <a:lstStyle/>
           <a:p>
             <a:r>
-              <a:rPr lang="en-US" smtClean="0"/>
+              <a:rPr lang="en-US"/>
               <a:t>Click to edit Master title style</a:t>
             </a:r>
-            <a:endParaRPr lang="en-US"/>
           </a:p>
         </p:txBody>
       </p:sp>
@@ -766,38 +775,37 @@
           <a:p>
             <a:pPr lvl="0"/>
             <a:r>
-              <a:rPr lang="en-US" smtClean="0"/>
+              <a:rPr lang="en-US"/>
               <a:t>Click to edit Master text styles</a:t>
             </a:r>
           </a:p>
           <a:p>
             <a:pPr lvl="1"/>
             <a:r>
-              <a:rPr lang="en-US" smtClean="0"/>
+              <a:rPr lang="en-US"/>
               <a:t>Second level</a:t>
             </a:r>
           </a:p>
           <a:p>
             <a:pPr lvl="2"/>
             <a:r>
-              <a:rPr lang="en-US" smtClean="0"/>
+              <a:rPr lang="en-US"/>
               <a:t>Third level</a:t>
             </a:r>
           </a:p>
           <a:p>
             <a:pPr lvl="3"/>
             <a:r>
-              <a:rPr lang="en-US" smtClean="0"/>
+              <a:rPr lang="en-US"/>
               <a:t>Fourth level</a:t>
             </a:r>
           </a:p>
           <a:p>
             <a:pPr lvl="4"/>
             <a:r>
-              <a:rPr lang="en-US" smtClean="0"/>
+              <a:rPr lang="en-US"/>
               <a:t>Fifth level</a:t>
             </a:r>
-            <a:endParaRPr lang="en-US"/>
           </a:p>
         </p:txBody>
       </p:sp>
@@ -818,7 +826,7 @@
           <a:p>
             <a:fld id="{5BCAD085-E8A6-8845-BD4E-CB4CCA059FC4}" type="datetimeFigureOut">
               <a:rPr lang="en-US" smtClean="0"/>
-              <a:t>1/27/13</a:t>
+              <a:t>5/25/2026</a:t>
             </a:fld>
             <a:endParaRPr lang="en-US"/>
           </a:p>
@@ -921,10 +929,9 @@
           </a:lstStyle>
           <a:p>
             <a:r>
-              <a:rPr lang="en-US" smtClean="0"/>
+              <a:rPr lang="en-US"/>
               <a:t>Click to edit Master title style</a:t>
             </a:r>
-            <a:endParaRPr lang="en-US"/>
           </a:p>
         </p:txBody>
       </p:sp>
@@ -1041,7 +1048,7 @@
           <a:p>
             <a:pPr lvl="0"/>
             <a:r>
-              <a:rPr lang="en-US" smtClean="0"/>
+              <a:rPr lang="en-US"/>
               <a:t>Click to edit Master text styles</a:t>
             </a:r>
           </a:p>
@@ -1064,7 +1071,7 @@
           <a:p>
             <a:fld id="{5BCAD085-E8A6-8845-BD4E-CB4CCA059FC4}" type="datetimeFigureOut">
               <a:rPr lang="en-US" smtClean="0"/>
-              <a:t>1/27/13</a:t>
+              <a:t>5/25/2026</a:t>
             </a:fld>
             <a:endParaRPr lang="en-US"/>
           </a:p>
@@ -1158,10 +1165,9 @@
           <a:lstStyle/>
           <a:p>
             <a:r>
-              <a:rPr lang="en-US" smtClean="0"/>
+              <a:rPr lang="en-US"/>
               <a:t>Click to edit Master title style</a:t>
             </a:r>
-            <a:endParaRPr lang="en-US"/>
           </a:p>
         </p:txBody>
       </p:sp>
@@ -1215,38 +1221,37 @@
           <a:p>
             <a:pPr lvl="0"/>
             <a:r>
-              <a:rPr lang="en-US" smtClean="0"/>
+              <a:rPr lang="en-US"/>
               <a:t>Click to edit Master text styles</a:t>
             </a:r>
           </a:p>
           <a:p>
             <a:pPr lvl="1"/>
             <a:r>
-              <a:rPr lang="en-US" smtClean="0"/>
+              <a:rPr lang="en-US"/>
               <a:t>Second level</a:t>
             </a:r>
           </a:p>
           <a:p>
             <a:pPr lvl="2"/>
             <a:r>
-              <a:rPr lang="en-US" smtClean="0"/>
+              <a:rPr lang="en-US"/>
               <a:t>Third level</a:t>
             </a:r>
           </a:p>
           <a:p>
             <a:pPr lvl="3"/>
             <a:r>
-              <a:rPr lang="en-US" smtClean="0"/>
+              <a:rPr lang="en-US"/>
               <a:t>Fourth level</a:t>
             </a:r>
           </a:p>
           <a:p>
             <a:pPr lvl="4"/>
             <a:r>
-              <a:rPr lang="en-US" smtClean="0"/>
+              <a:rPr lang="en-US"/>
               <a:t>Fifth level</a:t>
             </a:r>
-            <a:endParaRPr lang="en-US"/>
           </a:p>
         </p:txBody>
       </p:sp>
@@ -1300,38 +1305,37 @@
           <a:p>
             <a:pPr lvl="0"/>
             <a:r>
-              <a:rPr lang="en-US" smtClean="0"/>
+              <a:rPr lang="en-US"/>
               <a:t>Click to edit Master text styles</a:t>
             </a:r>
           </a:p>
           <a:p>
             <a:pPr lvl="1"/>
             <a:r>
-              <a:rPr lang="en-US" smtClean="0"/>
+              <a:rPr lang="en-US"/>
               <a:t>Second level</a:t>
             </a:r>
           </a:p>
           <a:p>
             <a:pPr lvl="2"/>
             <a:r>
-              <a:rPr lang="en-US" smtClean="0"/>
+              <a:rPr lang="en-US"/>
               <a:t>Third level</a:t>
             </a:r>
           </a:p>
           <a:p>
             <a:pPr lvl="3"/>
             <a:r>
-              <a:rPr lang="en-US" smtClean="0"/>
+              <a:rPr lang="en-US"/>
               <a:t>Fourth level</a:t>
             </a:r>
           </a:p>
           <a:p>
             <a:pPr lvl="4"/>
             <a:r>
-              <a:rPr lang="en-US" smtClean="0"/>
+              <a:rPr lang="en-US"/>
               <a:t>Fifth level</a:t>
             </a:r>
-            <a:endParaRPr lang="en-US"/>
           </a:p>
         </p:txBody>
       </p:sp>
@@ -1352,7 +1356,7 @@
           <a:p>
             <a:fld id="{5BCAD085-E8A6-8845-BD4E-CB4CCA059FC4}" type="datetimeFigureOut">
               <a:rPr lang="en-US" smtClean="0"/>
-              <a:t>1/27/13</a:t>
+              <a:t>5/25/2026</a:t>
             </a:fld>
             <a:endParaRPr lang="en-US"/>
           </a:p>
@@ -1450,10 +1454,9 @@
           </a:lstStyle>
           <a:p>
             <a:r>
-              <a:rPr lang="en-US" smtClean="0"/>
+              <a:rPr lang="en-US"/>
               <a:t>Click to edit Master title style</a:t>
             </a:r>
-            <a:endParaRPr lang="en-US"/>
           </a:p>
         </p:txBody>
       </p:sp>
@@ -1516,7 +1519,7 @@
           <a:p>
             <a:pPr lvl="0"/>
             <a:r>
-              <a:rPr lang="en-US" smtClean="0"/>
+              <a:rPr lang="en-US"/>
               <a:t>Click to edit Master text styles</a:t>
             </a:r>
           </a:p>
@@ -1572,38 +1575,37 @@
           <a:p>
             <a:pPr lvl="0"/>
             <a:r>
-              <a:rPr lang="en-US" smtClean="0"/>
+              <a:rPr lang="en-US"/>
               <a:t>Click to edit Master text styles</a:t>
             </a:r>
           </a:p>
           <a:p>
             <a:pPr lvl="1"/>
             <a:r>
-              <a:rPr lang="en-US" smtClean="0"/>
+              <a:rPr lang="en-US"/>
               <a:t>Second level</a:t>
             </a:r>
           </a:p>
           <a:p>
             <a:pPr lvl="2"/>
             <a:r>
-              <a:rPr lang="en-US" smtClean="0"/>
+              <a:rPr lang="en-US"/>
               <a:t>Third level</a:t>
             </a:r>
           </a:p>
           <a:p>
             <a:pPr lvl="3"/>
             <a:r>
-              <a:rPr lang="en-US" smtClean="0"/>
+              <a:rPr lang="en-US"/>
               <a:t>Fourth level</a:t>
             </a:r>
           </a:p>
           <a:p>
             <a:pPr lvl="4"/>
             <a:r>
-              <a:rPr lang="en-US" smtClean="0"/>
+              <a:rPr lang="en-US"/>
               <a:t>Fifth level</a:t>
             </a:r>
-            <a:endParaRPr lang="en-US"/>
           </a:p>
         </p:txBody>
       </p:sp>
@@ -1666,7 +1668,7 @@
           <a:p>
             <a:pPr lvl="0"/>
             <a:r>
-              <a:rPr lang="en-US" smtClean="0"/>
+              <a:rPr lang="en-US"/>
               <a:t>Click to edit Master text styles</a:t>
             </a:r>
           </a:p>
@@ -1722,38 +1724,37 @@
           <a:p>
             <a:pPr lvl="0"/>
             <a:r>
-              <a:rPr lang="en-US" smtClean="0"/>
+              <a:rPr lang="en-US"/>
               <a:t>Click to edit Master text styles</a:t>
             </a:r>
           </a:p>
           <a:p>
             <a:pPr lvl="1"/>
             <a:r>
-              <a:rPr lang="en-US" smtClean="0"/>
+              <a:rPr lang="en-US"/>
               <a:t>Second level</a:t>
             </a:r>
           </a:p>
           <a:p>
             <a:pPr lvl="2"/>
             <a:r>
-              <a:rPr lang="en-US" smtClean="0"/>
+              <a:rPr lang="en-US"/>
               <a:t>Third level</a:t>
             </a:r>
           </a:p>
           <a:p>
             <a:pPr lvl="3"/>
             <a:r>
-              <a:rPr lang="en-US" smtClean="0"/>
+              <a:rPr lang="en-US"/>
               <a:t>Fourth level</a:t>
             </a:r>
           </a:p>
           <a:p>
             <a:pPr lvl="4"/>
             <a:r>
-              <a:rPr lang="en-US" smtClean="0"/>
+              <a:rPr lang="en-US"/>
               <a:t>Fifth level</a:t>
             </a:r>
-            <a:endParaRPr lang="en-US"/>
           </a:p>
         </p:txBody>
       </p:sp>
@@ -1774,7 +1775,7 @@
           <a:p>
             <a:fld id="{5BCAD085-E8A6-8845-BD4E-CB4CCA059FC4}" type="datetimeFigureOut">
               <a:rPr lang="en-US" smtClean="0"/>
-              <a:t>1/27/13</a:t>
+              <a:t>5/25/2026</a:t>
             </a:fld>
             <a:endParaRPr lang="en-US"/>
           </a:p>
@@ -1868,10 +1869,9 @@
           <a:lstStyle/>
           <a:p>
             <a:r>
-              <a:rPr lang="en-US" smtClean="0"/>
+              <a:rPr lang="en-US"/>
               <a:t>Click to edit Master title style</a:t>
             </a:r>
-            <a:endParaRPr lang="en-US"/>
           </a:p>
         </p:txBody>
       </p:sp>
@@ -1892,7 +1892,7 @@
           <a:p>
             <a:fld id="{5BCAD085-E8A6-8845-BD4E-CB4CCA059FC4}" type="datetimeFigureOut">
               <a:rPr lang="en-US" smtClean="0"/>
-              <a:t>1/27/13</a:t>
+              <a:t>5/25/2026</a:t>
             </a:fld>
             <a:endParaRPr lang="en-US"/>
           </a:p>
@@ -1987,7 +1987,7 @@
           <a:p>
             <a:fld id="{5BCAD085-E8A6-8845-BD4E-CB4CCA059FC4}" type="datetimeFigureOut">
               <a:rPr lang="en-US" smtClean="0"/>
-              <a:t>1/27/13</a:t>
+              <a:t>5/25/2026</a:t>
             </a:fld>
             <a:endParaRPr lang="en-US"/>
           </a:p>
@@ -2090,10 +2090,9 @@
           </a:lstStyle>
           <a:p>
             <a:r>
-              <a:rPr lang="en-US" smtClean="0"/>
+              <a:rPr lang="en-US"/>
               <a:t>Click to edit Master title style</a:t>
             </a:r>
-            <a:endParaRPr lang="en-US"/>
           </a:p>
         </p:txBody>
       </p:sp>
@@ -2147,38 +2146,37 @@
           <a:p>
             <a:pPr lvl="0"/>
             <a:r>
-              <a:rPr lang="en-US" smtClean="0"/>
+              <a:rPr lang="en-US"/>
               <a:t>Click to edit Master text styles</a:t>
             </a:r>
           </a:p>
           <a:p>
             <a:pPr lvl="1"/>
             <a:r>
-              <a:rPr lang="en-US" smtClean="0"/>
+              <a:rPr lang="en-US"/>
               <a:t>Second level</a:t>
             </a:r>
           </a:p>
           <a:p>
             <a:pPr lvl="2"/>
             <a:r>
-              <a:rPr lang="en-US" smtClean="0"/>
+              <a:rPr lang="en-US"/>
               <a:t>Third level</a:t>
             </a:r>
           </a:p>
           <a:p>
             <a:pPr lvl="3"/>
             <a:r>
-              <a:rPr lang="en-US" smtClean="0"/>
+              <a:rPr lang="en-US"/>
               <a:t>Fourth level</a:t>
             </a:r>
           </a:p>
           <a:p>
             <a:pPr lvl="4"/>
             <a:r>
-              <a:rPr lang="en-US" smtClean="0"/>
+              <a:rPr lang="en-US"/>
               <a:t>Fifth level</a:t>
             </a:r>
-            <a:endParaRPr lang="en-US"/>
           </a:p>
         </p:txBody>
       </p:sp>
@@ -2241,7 +2239,7 @@
           <a:p>
             <a:pPr lvl="0"/>
             <a:r>
-              <a:rPr lang="en-US" smtClean="0"/>
+              <a:rPr lang="en-US"/>
               <a:t>Click to edit Master text styles</a:t>
             </a:r>
           </a:p>
@@ -2264,7 +2262,7 @@
           <a:p>
             <a:fld id="{5BCAD085-E8A6-8845-BD4E-CB4CCA059FC4}" type="datetimeFigureOut">
               <a:rPr lang="en-US" smtClean="0"/>
-              <a:t>1/27/13</a:t>
+              <a:t>5/25/2026</a:t>
             </a:fld>
             <a:endParaRPr lang="en-US"/>
           </a:p>
@@ -2367,10 +2365,9 @@
           </a:lstStyle>
           <a:p>
             <a:r>
-              <a:rPr lang="en-US" smtClean="0"/>
+              <a:rPr lang="en-US"/>
               <a:t>Click to edit Master title style</a:t>
             </a:r>
-            <a:endParaRPr lang="en-US"/>
           </a:p>
         </p:txBody>
       </p:sp>
@@ -2494,7 +2491,7 @@
           <a:p>
             <a:pPr lvl="0"/>
             <a:r>
-              <a:rPr lang="en-US" smtClean="0"/>
+              <a:rPr lang="en-US"/>
               <a:t>Click to edit Master text styles</a:t>
             </a:r>
           </a:p>
@@ -2517,7 +2514,7 @@
           <a:p>
             <a:fld id="{5BCAD085-E8A6-8845-BD4E-CB4CCA059FC4}" type="datetimeFigureOut">
               <a:rPr lang="en-US" smtClean="0"/>
-              <a:t>1/27/13</a:t>
+              <a:t>5/25/2026</a:t>
             </a:fld>
             <a:endParaRPr lang="en-US"/>
           </a:p>
@@ -2626,10 +2623,9 @@
           <a:lstStyle/>
           <a:p>
             <a:r>
-              <a:rPr lang="en-US" smtClean="0"/>
+              <a:rPr lang="en-US"/>
               <a:t>Click to edit Master title style</a:t>
             </a:r>
-            <a:endParaRPr lang="en-US"/>
           </a:p>
         </p:txBody>
       </p:sp>
@@ -2660,38 +2656,37 @@
           <a:p>
             <a:pPr lvl="0"/>
             <a:r>
-              <a:rPr lang="en-US" smtClean="0"/>
+              <a:rPr lang="en-US"/>
               <a:t>Click to edit Master text styles</a:t>
             </a:r>
           </a:p>
           <a:p>
             <a:pPr lvl="1"/>
             <a:r>
-              <a:rPr lang="en-US" smtClean="0"/>
+              <a:rPr lang="en-US"/>
               <a:t>Second level</a:t>
             </a:r>
           </a:p>
           <a:p>
             <a:pPr lvl="2"/>
             <a:r>
-              <a:rPr lang="en-US" smtClean="0"/>
+              <a:rPr lang="en-US"/>
               <a:t>Third level</a:t>
             </a:r>
           </a:p>
           <a:p>
             <a:pPr lvl="3"/>
             <a:r>
-              <a:rPr lang="en-US" smtClean="0"/>
+              <a:rPr lang="en-US"/>
               <a:t>Fourth level</a:t>
             </a:r>
           </a:p>
           <a:p>
             <a:pPr lvl="4"/>
             <a:r>
-              <a:rPr lang="en-US" smtClean="0"/>
+              <a:rPr lang="en-US"/>
               <a:t>Fifth level</a:t>
             </a:r>
-            <a:endParaRPr lang="en-US"/>
           </a:p>
         </p:txBody>
       </p:sp>
@@ -2730,7 +2725,7 @@
           <a:p>
             <a:fld id="{5BCAD085-E8A6-8845-BD4E-CB4CCA059FC4}" type="datetimeFigureOut">
               <a:rPr lang="en-US" smtClean="0"/>
-              <a:t>1/27/13</a:t>
+              <a:t>5/25/2026</a:t>
             </a:fld>
             <a:endParaRPr lang="en-US"/>
           </a:p>
@@ -3089,7 +3084,7 @@
 </file>
 
 <file path=ppt/slides/slide1.xml><?xml version="1.0" encoding="utf-8"?>
-<p:sld xmlns:a="http://schemas.openxmlformats.org/drawingml/2006/main" xmlns:p="http://schemas.openxmlformats.org/presentationml/2006/main" xmlns:r="http://schemas.openxmlformats.org/officeDocument/2006/relationships">
+<p:sld xmlns:a="http://schemas.openxmlformats.org/drawingml/2006/main" xmlns:r="http://schemas.openxmlformats.org/officeDocument/2006/relationships" xmlns:p="http://schemas.openxmlformats.org/presentationml/2006/main">
   <p:cSld>
     <p:spTree>
       <p:nvGrpSpPr>
@@ -3097,7 +3092,14 @@
         <p:cNvGrpSpPr/>
         <p:nvPr/>
       </p:nvGrpSpPr>
-      <p:grpSpPr/>
+      <p:grpSpPr>
+        <a:xfrm>
+          <a:off x="0" y="0"/>
+          <a:ext cx="0" cy="0"/>
+          <a:chOff x="0" y="0"/>
+          <a:chExt cx="0" cy="0"/>
+        </a:xfrm>
+      </p:grpSpPr>
       <p:pic>
         <p:nvPicPr>
           <p:cNvPr id="2" name="Picture 1" descr="bg_0.png"/>
@@ -3286,7 +3288,7 @@
         <p:spPr>
           <a:xfrm>
             <a:off x="2013197" y="2404616"/>
-            <a:ext cx="8165454" cy="1268610"/>
+            <a:ext cx="8165454" cy="1292662"/>
           </a:xfrm>
           <a:prstGeom prst="rect">
             <a:avLst/>
@@ -3307,7 +3309,15 @@
               </a:defRPr>
             </a:pPr>
             <a:r>
+              <a:rPr lang="en-US" dirty="0"/>
               <a:t>Secure File Encryption System</a:t>
+            </a:r>
+            <a:br>
+              <a:rPr lang="en-US" dirty="0"/>
+            </a:br>
+            <a:r>
+              <a:rPr lang="en-US" dirty="0"/>
+              <a:t>using Hybrid Cryptography</a:t>
             </a:r>
           </a:p>
         </p:txBody>
@@ -3355,7 +3365,7 @@
         </p:nvSpPr>
         <p:spPr>
           <a:xfrm>
-            <a:off x="3412330" y="4391322"/>
+            <a:off x="3436520" y="4430026"/>
             <a:ext cx="935235" cy="333375"/>
           </a:xfrm>
           <a:prstGeom prst="rect">
@@ -3377,6 +3387,7 @@
               </a:defRPr>
             </a:pPr>
             <a:r>
+              <a:rPr dirty="0"/>
               <a:t>RSA-2048</a:t>
             </a:r>
           </a:p>
@@ -3390,7 +3401,7 @@
         </p:nvSpPr>
         <p:spPr>
           <a:xfrm>
-            <a:off x="4461866" y="4391322"/>
+            <a:off x="4486056" y="4430026"/>
             <a:ext cx="1178867" cy="333375"/>
           </a:xfrm>
           <a:prstGeom prst="rect">
@@ -3425,7 +3436,7 @@
         </p:nvSpPr>
         <p:spPr>
           <a:xfrm>
-            <a:off x="5755034" y="4391322"/>
+            <a:off x="5759872" y="4430026"/>
             <a:ext cx="1254323" cy="333375"/>
           </a:xfrm>
           <a:prstGeom prst="rect">
@@ -3447,6 +3458,7 @@
               </a:defRPr>
             </a:pPr>
             <a:r>
+              <a:rPr dirty="0"/>
               <a:t>HMAC-SHA256</a:t>
             </a:r>
           </a:p>
@@ -3460,7 +3472,7 @@
         </p:nvSpPr>
         <p:spPr>
           <a:xfrm>
-            <a:off x="7123657" y="4391322"/>
+            <a:off x="7263959" y="4430026"/>
             <a:ext cx="1656010" cy="333375"/>
           </a:xfrm>
           <a:prstGeom prst="rect">
@@ -3496,20 +3508,34 @@
         <p:spPr>
           <a:xfrm>
             <a:off x="3383755" y="5410497"/>
-            <a:ext cx="5424338" cy="338137"/>
-          </a:xfrm>
-          <a:prstGeom prst="rect">
-            <a:avLst/>
-          </a:prstGeom>
-          <a:noFill/>
-        </p:spPr>
-        <p:txBody>
-          <a:bodyPr wrap="square" lIns="0" tIns="0" rIns="0" bIns="0">
-            <a:spAutoFit/>
-          </a:bodyPr>
-          <a:lstStyle/>
-          <a:p>
-            <a:pPr algn="ctr">
+            <a:ext cx="5624778" cy="215444"/>
+          </a:xfrm>
+          <a:prstGeom prst="rect">
+            <a:avLst/>
+          </a:prstGeom>
+          <a:noFill/>
+        </p:spPr>
+        <p:txBody>
+          <a:bodyPr wrap="square" lIns="0" tIns="0" rIns="0" bIns="0">
+            <a:spAutoFit/>
+          </a:bodyPr>
+          <a:lstStyle/>
+          <a:p>
+            <a:pPr marL="0" marR="0" lvl="0" indent="0" algn="ctr" defTabSz="457200" rtl="0" eaLnBrk="1" fontAlgn="auto" latinLnBrk="0" hangingPunct="1">
+              <a:lnSpc>
+                <a:spcPct val="100000"/>
+              </a:lnSpc>
+              <a:spcBef>
+                <a:spcPts val="0"/>
+              </a:spcBef>
+              <a:spcAft>
+                <a:spcPts val="0"/>
+              </a:spcAft>
+              <a:buClrTx/>
+              <a:buSzTx/>
+              <a:buFontTx/>
+              <a:buNone/>
+              <a:tabLst/>
               <a:defRPr sz="1125">
                 <a:solidFill>
                   <a:srgbClr val="8B949E"/>
@@ -3517,7 +3543,89 @@
               </a:defRPr>
             </a:pPr>
             <a:r>
-              <a:t>Presented by:  &amp;</a:t>
+              <a:rPr kumimoji="0" lang="en-US" sz="1400" b="0" i="0" u="none" strike="noStrike" kern="1200" cap="none" spc="0" normalizeH="0" baseline="0" noProof="0" dirty="0">
+                <a:ln>
+                  <a:noFill/>
+                </a:ln>
+                <a:solidFill>
+                  <a:srgbClr val="8B949E"/>
+                </a:solidFill>
+                <a:effectLst/>
+                <a:uLnTx/>
+                <a:uFillTx/>
+                <a:latin typeface="Calibri"/>
+                <a:ea typeface="+mn-ea"/>
+                <a:cs typeface="+mn-cs"/>
+              </a:rPr>
+              <a:t>Presented by: Waqas Ul Hasan (FA23-BCS-167) &amp; </a:t>
+            </a:r>
+            <a:r>
+              <a:rPr kumimoji="0" lang="en-US" sz="1400" b="0" i="0" u="none" strike="noStrike" kern="1200" cap="none" spc="0" normalizeH="0" baseline="0" noProof="0" dirty="0" err="1">
+                <a:ln>
+                  <a:noFill/>
+                </a:ln>
+                <a:solidFill>
+                  <a:srgbClr val="8B949E"/>
+                </a:solidFill>
+                <a:effectLst/>
+                <a:uLnTx/>
+                <a:uFillTx/>
+                <a:latin typeface="Calibri"/>
+                <a:ea typeface="+mn-ea"/>
+                <a:cs typeface="+mn-cs"/>
+              </a:rPr>
+              <a:t>Qurat</a:t>
+            </a:r>
+            <a:r>
+              <a:rPr kumimoji="0" lang="en-US" sz="1400" b="0" i="0" u="none" strike="noStrike" kern="1200" cap="none" spc="0" normalizeH="0" baseline="0" noProof="0" dirty="0">
+                <a:ln>
+                  <a:noFill/>
+                </a:ln>
+                <a:solidFill>
+                  <a:srgbClr val="8B949E"/>
+                </a:solidFill>
+                <a:effectLst/>
+                <a:uLnTx/>
+                <a:uFillTx/>
+                <a:latin typeface="Calibri"/>
+                <a:ea typeface="+mn-ea"/>
+                <a:cs typeface="+mn-cs"/>
+              </a:rPr>
+              <a:t> Ul </a:t>
+            </a:r>
+            <a:r>
+              <a:rPr kumimoji="0" lang="en-US" sz="1400" b="0" i="0" u="none" strike="noStrike" kern="1200" cap="none" spc="0" normalizeH="0" baseline="0" noProof="0" dirty="0" err="1">
+                <a:ln>
+                  <a:noFill/>
+                </a:ln>
+                <a:solidFill>
+                  <a:srgbClr val="8B949E"/>
+                </a:solidFill>
+                <a:effectLst/>
+                <a:uLnTx/>
+                <a:uFillTx/>
+                <a:latin typeface="Calibri"/>
+                <a:ea typeface="+mn-ea"/>
+                <a:cs typeface="+mn-cs"/>
+              </a:rPr>
+              <a:t>ain</a:t>
+            </a:r>
+            <a:r>
+              <a:rPr kumimoji="0" lang="en-US" sz="1400" b="0" i="0" u="none" strike="noStrike" kern="1200" cap="none" spc="0" normalizeH="0" baseline="0" noProof="0" dirty="0">
+                <a:ln>
+                  <a:noFill/>
+                </a:ln>
+                <a:solidFill>
+                  <a:srgbClr val="8B949E"/>
+                </a:solidFill>
+                <a:effectLst/>
+                <a:uLnTx/>
+                <a:uFillTx/>
+                <a:latin typeface="Calibri"/>
+                <a:ea typeface="+mn-ea"/>
+                <a:cs typeface="+mn-cs"/>
+              </a:rPr>
+              <a:t> (FA23-BCS-195)</a:t>
             </a:r>
           </a:p>
         </p:txBody>
@@ -3531,7 +3639,7 @@
 </file>
 
 <file path=ppt/slides/slide10.xml><?xml version="1.0" encoding="utf-8"?>
-<p:sld xmlns:a="http://schemas.openxmlformats.org/drawingml/2006/main" xmlns:p="http://schemas.openxmlformats.org/presentationml/2006/main" xmlns:r="http://schemas.openxmlformats.org/officeDocument/2006/relationships">
+<p:sld xmlns:a="http://schemas.openxmlformats.org/drawingml/2006/main" xmlns:r="http://schemas.openxmlformats.org/officeDocument/2006/relationships" xmlns:p="http://schemas.openxmlformats.org/presentationml/2006/main">
   <p:cSld>
     <p:spTree>
       <p:nvGrpSpPr>
@@ -3539,7 +3647,14 @@
         <p:cNvGrpSpPr/>
         <p:nvPr/>
       </p:nvGrpSpPr>
-      <p:grpSpPr/>
+      <p:grpSpPr>
+        <a:xfrm>
+          <a:off x="0" y="0"/>
+          <a:ext cx="0" cy="0"/>
+          <a:chOff x="0" y="0"/>
+          <a:chExt cx="0" cy="0"/>
+        </a:xfrm>
+      </p:grpSpPr>
       <p:pic>
         <p:nvPicPr>
           <p:cNvPr id="2" name="Picture 1" descr="bg_1.png"/>
@@ -3788,21 +3903,21 @@
         </p:nvSpPr>
         <p:spPr>
           <a:xfrm>
-            <a:off x="761999" y="1037629"/>
-            <a:ext cx="938510" cy="333375"/>
-          </a:xfrm>
-          <a:prstGeom prst="rect">
-            <a:avLst/>
-          </a:prstGeom>
-          <a:noFill/>
-        </p:spPr>
-        <p:txBody>
-          <a:bodyPr wrap="square" lIns="0" tIns="0" rIns="0" bIns="0">
-            <a:spAutoFit/>
-          </a:bodyPr>
-          <a:lstStyle/>
-          <a:p>
-            <a:pPr algn="l">
+            <a:off x="761999" y="1095685"/>
+            <a:ext cx="938510" cy="138499"/>
+          </a:xfrm>
+          <a:prstGeom prst="rect">
+            <a:avLst/>
+          </a:prstGeom>
+          <a:noFill/>
+        </p:spPr>
+        <p:txBody>
+          <a:bodyPr wrap="square" lIns="0" tIns="0" rIns="0" bIns="0">
+            <a:spAutoFit/>
+          </a:bodyPr>
+          <a:lstStyle/>
+          <a:p>
+            <a:pPr algn="ctr">
               <a:defRPr sz="900" b="1">
                 <a:solidFill>
                   <a:srgbClr val="58A6FF"/>
@@ -3845,6 +3960,7 @@
               </a:defRPr>
             </a:pPr>
             <a:r>
+              <a:rPr dirty="0"/>
               <a:t>Security</a:t>
             </a:r>
           </a:p>
@@ -3880,6 +3996,7 @@
               </a:defRPr>
             </a:pPr>
             <a:r>
+              <a:rPr dirty="0"/>
               <a:t>Strengths</a:t>
             </a:r>
           </a:p>
@@ -4020,6 +4137,7 @@
               </a:defRPr>
             </a:pPr>
             <a:r>
+              <a:rPr dirty="0"/>
               <a:t>HIGH</a:t>
             </a:r>
           </a:p>
@@ -4230,6 +4348,7 @@
               </a:defRPr>
             </a:pPr>
             <a:r>
+              <a:rPr dirty="0"/>
               <a:t>MAX</a:t>
             </a:r>
           </a:p>
@@ -4244,7 +4363,7 @@
         <p:spPr>
           <a:xfrm>
             <a:off x="6524624" y="2390179"/>
-            <a:ext cx="4629149" cy="371475"/>
+            <a:ext cx="4629149" cy="276999"/>
           </a:xfrm>
           <a:prstGeom prst="rect">
             <a:avLst/>
@@ -4265,7 +4384,8 @@
               </a:defRPr>
             </a:pPr>
             <a:r>
-              <a:t>Known Limitations</a:t>
+              <a:rPr dirty="0"/>
+              <a:t>Limitations</a:t>
             </a:r>
           </a:p>
         </p:txBody>
@@ -4279,7 +4399,7 @@
         <p:spPr>
           <a:xfrm>
             <a:off x="6524624" y="2780704"/>
-            <a:ext cx="4629149" cy="986432"/>
+            <a:ext cx="4629149" cy="677108"/>
           </a:xfrm>
           <a:prstGeom prst="rect">
             <a:avLst/>
@@ -4300,18 +4420,28 @@
               </a:defRPr>
             </a:pPr>
             <a:r>
+              <a:rPr sz="1100" dirty="0"/>
               <a:t>• Private key stored unencrypted on disk</a:t>
             </a:r>
-            <a:br/>
-            <a:r>
+            <a:br>
+              <a:rPr sz="1100" dirty="0"/>
+            </a:br>
+            <a:r>
+              <a:rPr sz="1100" dirty="0"/>
               <a:t>            • No perfect forward secrecy (RSA reuse)</a:t>
             </a:r>
-            <a:br/>
-            <a:r>
+            <a:br>
+              <a:rPr sz="1100" dirty="0"/>
+            </a:br>
+            <a:r>
+              <a:rPr sz="1100" dirty="0"/>
               <a:t>            • No key revocation mechanism</a:t>
             </a:r>
-            <a:br/>
-            <a:r>
+            <a:br>
+              <a:rPr sz="1100" dirty="0"/>
+            </a:br>
+            <a:r>
+              <a:rPr sz="1100" dirty="0"/>
               <a:t>            • Single-recipient encryption only</a:t>
             </a:r>
           </a:p>
@@ -4326,7 +4456,7 @@
         <p:spPr>
           <a:xfrm>
             <a:off x="6524624" y="4300537"/>
-            <a:ext cx="4629149" cy="371475"/>
+            <a:ext cx="4629149" cy="276999"/>
           </a:xfrm>
           <a:prstGeom prst="rect">
             <a:avLst/>
@@ -4347,7 +4477,8 @@
               </a:defRPr>
             </a:pPr>
             <a:r>
-              <a:t>Future Improvements</a:t>
+              <a:rPr dirty="0"/>
+              <a:t>Improvements</a:t>
             </a:r>
           </a:p>
         </p:txBody>
@@ -4361,7 +4492,7 @@
         <p:spPr>
           <a:xfrm>
             <a:off x="6524624" y="4691062"/>
-            <a:ext cx="4629149" cy="986432"/>
+            <a:ext cx="4629149" cy="677108"/>
           </a:xfrm>
           <a:prstGeom prst="rect">
             <a:avLst/>
@@ -4382,18 +4513,28 @@
               </a:defRPr>
             </a:pPr>
             <a:r>
+              <a:rPr sz="1100"/>
               <a:t>• Passphrase-protected private key (AES-256-GCM wrapping)</a:t>
             </a:r>
-            <a:br/>
-            <a:r>
+            <a:br>
+              <a:rPr sz="1100"/>
+            </a:br>
+            <a:r>
+              <a:rPr sz="1100"/>
               <a:t>            • Digital signatures (RSA + SHA-256)</a:t>
             </a:r>
-            <a:br/>
-            <a:r>
+            <a:br>
+              <a:rPr sz="1100"/>
+            </a:br>
+            <a:r>
+              <a:rPr sz="1100"/>
               <a:t>            • Elliptic Curve Cryptography (ECDH)</a:t>
             </a:r>
-            <a:br/>
-            <a:r>
+            <a:br>
+              <a:rPr sz="1100"/>
+            </a:br>
+            <a:r>
+              <a:rPr sz="1100"/>
               <a:t>            • Multi-recipient support</a:t>
             </a:r>
           </a:p>
@@ -4408,7 +4549,7 @@
 </file>
 
 <file path=ppt/slides/slide11.xml><?xml version="1.0" encoding="utf-8"?>
-<p:sld xmlns:a="http://schemas.openxmlformats.org/drawingml/2006/main" xmlns:p="http://schemas.openxmlformats.org/presentationml/2006/main" xmlns:r="http://schemas.openxmlformats.org/officeDocument/2006/relationships">
+<p:sld xmlns:a="http://schemas.openxmlformats.org/drawingml/2006/main" xmlns:r="http://schemas.openxmlformats.org/officeDocument/2006/relationships" xmlns:p="http://schemas.openxmlformats.org/presentationml/2006/main">
   <p:cSld>
     <p:spTree>
       <p:nvGrpSpPr>
@@ -4416,7 +4557,14 @@
         <p:cNvGrpSpPr/>
         <p:nvPr/>
       </p:nvGrpSpPr>
-      <p:grpSpPr/>
+      <p:grpSpPr>
+        <a:xfrm>
+          <a:off x="0" y="0"/>
+          <a:ext cx="0" cy="0"/>
+          <a:chOff x="0" y="0"/>
+          <a:chExt cx="0" cy="0"/>
+        </a:xfrm>
+      </p:grpSpPr>
       <p:pic>
         <p:nvPicPr>
           <p:cNvPr id="2" name="Picture 1" descr="bg_10.png"/>
@@ -4567,6 +4715,7 @@
               </a:defRPr>
             </a:pPr>
             <a:r>
+              <a:rPr dirty="0"/>
               <a:t>✅</a:t>
             </a:r>
           </a:p>
@@ -4602,6 +4751,7 @@
               </a:defRPr>
             </a:pPr>
             <a:r>
+              <a:rPr dirty="0"/>
               <a:t>Project</a:t>
             </a:r>
           </a:p>
@@ -4637,6 +4787,7 @@
               </a:defRPr>
             </a:pPr>
             <a:r>
+              <a:rPr dirty="0"/>
               <a:t>We successfully implemented a  combining RSA-2048, AES-256-CBC, and HMAC-SHA256. The system provides confidentiality, integrity, and authenticity for any file type.</a:t>
             </a:r>
           </a:p>
@@ -4672,6 +4823,7 @@
               </a:defRPr>
             </a:pPr>
             <a:r>
+              <a:rPr dirty="0"/>
               <a:t>Information Security — Group Project  |  2026</a:t>
             </a:r>
           </a:p>
@@ -4686,7 +4838,7 @@
 </file>
 
 <file path=ppt/slides/slide2.xml><?xml version="1.0" encoding="utf-8"?>
-<p:sld xmlns:a="http://schemas.openxmlformats.org/drawingml/2006/main" xmlns:p="http://schemas.openxmlformats.org/presentationml/2006/main" xmlns:r="http://schemas.openxmlformats.org/officeDocument/2006/relationships">
+<p:sld xmlns:a="http://schemas.openxmlformats.org/drawingml/2006/main" xmlns:r="http://schemas.openxmlformats.org/officeDocument/2006/relationships" xmlns:p="http://schemas.openxmlformats.org/presentationml/2006/main">
   <p:cSld>
     <p:spTree>
       <p:nvGrpSpPr>
@@ -4694,7 +4846,14 @@
         <p:cNvGrpSpPr/>
         <p:nvPr/>
       </p:nvGrpSpPr>
-      <p:grpSpPr/>
+      <p:grpSpPr>
+        <a:xfrm>
+          <a:off x="0" y="0"/>
+          <a:ext cx="0" cy="0"/>
+          <a:chOff x="0" y="0"/>
+          <a:chExt cx="0" cy="0"/>
+        </a:xfrm>
+      </p:grpSpPr>
       <p:pic>
         <p:nvPicPr>
           <p:cNvPr id="2" name="Picture 1" descr="bg_1.png"/>
@@ -4919,7 +5078,7 @@
         </p:nvSpPr>
         <p:spPr>
           <a:xfrm>
-            <a:off x="761999" y="1253132"/>
+            <a:off x="1013576" y="1296675"/>
             <a:ext cx="1289000" cy="333375"/>
           </a:xfrm>
           <a:prstGeom prst="rect">
@@ -4941,6 +5100,7 @@
               </a:defRPr>
             </a:pPr>
             <a:r>
+              <a:rPr dirty="0"/>
               <a:t>INTRODUCTION</a:t>
             </a:r>
           </a:p>
@@ -5011,6 +5171,7 @@
               </a:defRPr>
             </a:pPr>
             <a:r>
+              <a:rPr dirty="0"/>
               <a:t>🌐</a:t>
             </a:r>
           </a:p>
@@ -5305,20 +5466,34 @@
         <p:spPr>
           <a:xfrm>
             <a:off x="1038224" y="5107632"/>
-            <a:ext cx="10115549" cy="354210"/>
-          </a:xfrm>
-          <a:prstGeom prst="rect">
-            <a:avLst/>
-          </a:prstGeom>
-          <a:noFill/>
-        </p:spPr>
-        <p:txBody>
-          <a:bodyPr wrap="square" lIns="0" tIns="0" rIns="0" bIns="0">
-            <a:spAutoFit/>
-          </a:bodyPr>
-          <a:lstStyle/>
-          <a:p>
-            <a:pPr algn="ctr">
+            <a:ext cx="10115549" cy="215444"/>
+          </a:xfrm>
+          <a:prstGeom prst="rect">
+            <a:avLst/>
+          </a:prstGeom>
+          <a:noFill/>
+        </p:spPr>
+        <p:txBody>
+          <a:bodyPr wrap="square" lIns="0" tIns="0" rIns="0" bIns="0">
+            <a:spAutoFit/>
+          </a:bodyPr>
+          <a:lstStyle/>
+          <a:p>
+            <a:pPr marL="0" marR="0" lvl="0" indent="0" algn="ctr" defTabSz="457200" rtl="0" eaLnBrk="1" fontAlgn="auto" latinLnBrk="0" hangingPunct="1">
+              <a:lnSpc>
+                <a:spcPct val="100000"/>
+              </a:lnSpc>
+              <a:spcBef>
+                <a:spcPts val="0"/>
+              </a:spcBef>
+              <a:spcAft>
+                <a:spcPts val="0"/>
+              </a:spcAft>
+              <a:buClrTx/>
+              <a:buSzTx/>
+              <a:buFontTx/>
+              <a:buNone/>
+              <a:tabLst/>
               <a:defRPr sz="1200">
                 <a:solidFill>
                   <a:srgbClr val="8B949E"/>
@@ -5326,7 +5501,21 @@
               </a:defRPr>
             </a:pPr>
             <a:r>
-              <a:t>Combine symmetric speed with asymmetric security —</a:t>
+              <a:rPr kumimoji="0" lang="en-US" sz="1400" b="0" i="0" u="none" strike="noStrike" kern="1200" cap="none" spc="0" normalizeH="0" baseline="0" noProof="0" dirty="0">
+                <a:ln>
+                  <a:noFill/>
+                </a:ln>
+                <a:solidFill>
+                  <a:srgbClr val="8B949E"/>
+                </a:solidFill>
+                <a:effectLst/>
+                <a:uLnTx/>
+                <a:uFillTx/>
+                <a:latin typeface="Calibri"/>
+                <a:ea typeface="+mn-ea"/>
+                <a:cs typeface="+mn-cs"/>
+              </a:rPr>
+              <a:t>Solution: Combine symmetric speed with asymmetric security — Hybrid Cryptography</a:t>
             </a:r>
           </a:p>
         </p:txBody>
@@ -5340,7 +5529,7 @@
 </file>
 
 <file path=ppt/slides/slide3.xml><?xml version="1.0" encoding="utf-8"?>
-<p:sld xmlns:a="http://schemas.openxmlformats.org/drawingml/2006/main" xmlns:p="http://schemas.openxmlformats.org/presentationml/2006/main" xmlns:r="http://schemas.openxmlformats.org/officeDocument/2006/relationships">
+<p:sld xmlns:a="http://schemas.openxmlformats.org/drawingml/2006/main" xmlns:r="http://schemas.openxmlformats.org/officeDocument/2006/relationships" xmlns:p="http://schemas.openxmlformats.org/presentationml/2006/main">
   <p:cSld>
     <p:spTree>
       <p:nvGrpSpPr>
@@ -5348,7 +5537,14 @@
         <p:cNvGrpSpPr/>
         <p:nvPr/>
       </p:nvGrpSpPr>
-      <p:grpSpPr/>
+      <p:grpSpPr>
+        <a:xfrm>
+          <a:off x="0" y="0"/>
+          <a:ext cx="0" cy="0"/>
+          <a:chOff x="0" y="0"/>
+          <a:chExt cx="0" cy="0"/>
+        </a:xfrm>
+      </p:grpSpPr>
       <p:pic>
         <p:nvPicPr>
           <p:cNvPr id="2" name="Picture 1" descr="bg_1.png"/>
@@ -5669,7 +5865,7 @@
         </p:nvSpPr>
         <p:spPr>
           <a:xfrm>
-            <a:off x="761999" y="952500"/>
+            <a:off x="955519" y="996042"/>
             <a:ext cx="813643" cy="333375"/>
           </a:xfrm>
           <a:prstGeom prst="rect">
@@ -5691,6 +5887,7 @@
               </a:defRPr>
             </a:pPr>
             <a:r>
+              <a:rPr dirty="0"/>
               <a:t>THEORY</a:t>
             </a:r>
           </a:p>
@@ -5726,6 +5923,7 @@
               </a:defRPr>
             </a:pPr>
             <a:r>
+              <a:rPr dirty="0"/>
               <a:t>Why  Cryptography?</a:t>
             </a:r>
           </a:p>
@@ -5774,8 +5972,8 @@
         </p:nvSpPr>
         <p:spPr>
           <a:xfrm>
-            <a:off x="1038224" y="2695575"/>
-            <a:ext cx="4629149" cy="471487"/>
+            <a:off x="1038224" y="2802011"/>
+            <a:ext cx="4629149" cy="161583"/>
           </a:xfrm>
           <a:prstGeom prst="rect">
             <a:avLst/>
@@ -5796,6 +5994,7 @@
               </a:defRPr>
             </a:pPr>
             <a:r>
+              <a:rPr sz="1050"/>
               <a:t>✅ Extremely fast</a:t>
             </a:r>
           </a:p>
@@ -5809,8 +6008,8 @@
         </p:nvSpPr>
         <p:spPr>
           <a:xfrm>
-            <a:off x="1038224" y="3071812"/>
-            <a:ext cx="4629149" cy="476250"/>
+            <a:off x="1038224" y="3178248"/>
+            <a:ext cx="4629149" cy="161583"/>
           </a:xfrm>
           <a:prstGeom prst="rect">
             <a:avLst/>
@@ -5831,6 +6030,7 @@
               </a:defRPr>
             </a:pPr>
             <a:r>
+              <a:rPr sz="1050"/>
               <a:t>✅ Handles any file size</a:t>
             </a:r>
           </a:p>
@@ -5844,8 +6044,8 @@
         </p:nvSpPr>
         <p:spPr>
           <a:xfrm>
-            <a:off x="1038224" y="3452812"/>
-            <a:ext cx="4629149" cy="476250"/>
+            <a:off x="1038224" y="3559248"/>
+            <a:ext cx="4629149" cy="161583"/>
           </a:xfrm>
           <a:prstGeom prst="rect">
             <a:avLst/>
@@ -5866,6 +6066,7 @@
               </a:defRPr>
             </a:pPr>
             <a:r>
+              <a:rPr sz="1050"/>
               <a:t>✅ Low CPU overhead</a:t>
             </a:r>
           </a:p>
@@ -5879,8 +6080,8 @@
         </p:nvSpPr>
         <p:spPr>
           <a:xfrm>
-            <a:off x="1038224" y="3833812"/>
-            <a:ext cx="4629149" cy="476250"/>
+            <a:off x="1038224" y="3940248"/>
+            <a:ext cx="4629149" cy="161583"/>
           </a:xfrm>
           <a:prstGeom prst="rect">
             <a:avLst/>
@@ -5901,6 +6102,7 @@
               </a:defRPr>
             </a:pPr>
             <a:r>
+              <a:rPr sz="1050"/>
               <a:t>❌ Key distribution problem</a:t>
             </a:r>
           </a:p>
@@ -5914,8 +6116,8 @@
         </p:nvSpPr>
         <p:spPr>
           <a:xfrm>
-            <a:off x="1038224" y="4214812"/>
-            <a:ext cx="4629149" cy="471487"/>
+            <a:off x="1038224" y="4321248"/>
+            <a:ext cx="4629149" cy="161583"/>
           </a:xfrm>
           <a:prstGeom prst="rect">
             <a:avLst/>
@@ -5936,6 +6138,7 @@
               </a:defRPr>
             </a:pPr>
             <a:r>
+              <a:rPr sz="1050"/>
               <a:t>❌ Both parties need same key</a:t>
             </a:r>
           </a:p>
@@ -5984,8 +6187,8 @@
         </p:nvSpPr>
         <p:spPr>
           <a:xfrm>
-            <a:off x="6524624" y="2695575"/>
-            <a:ext cx="4629149" cy="471487"/>
+            <a:off x="6524624" y="2802011"/>
+            <a:ext cx="4629149" cy="161583"/>
           </a:xfrm>
           <a:prstGeom prst="rect">
             <a:avLst/>
@@ -6006,6 +6209,7 @@
               </a:defRPr>
             </a:pPr>
             <a:r>
+              <a:rPr sz="1050"/>
               <a:t>✅ Solves key distribution</a:t>
             </a:r>
           </a:p>
@@ -6019,8 +6223,8 @@
         </p:nvSpPr>
         <p:spPr>
           <a:xfrm>
-            <a:off x="6524624" y="3071812"/>
-            <a:ext cx="4629149" cy="476250"/>
+            <a:off x="6524624" y="3178248"/>
+            <a:ext cx="4629149" cy="161583"/>
           </a:xfrm>
           <a:prstGeom prst="rect">
             <a:avLst/>
@@ -6041,6 +6245,7 @@
               </a:defRPr>
             </a:pPr>
             <a:r>
+              <a:rPr sz="1050"/>
               <a:t>✅ Public key freely shared</a:t>
             </a:r>
           </a:p>
@@ -6054,8 +6259,8 @@
         </p:nvSpPr>
         <p:spPr>
           <a:xfrm>
-            <a:off x="6524624" y="3452812"/>
-            <a:ext cx="4629149" cy="476250"/>
+            <a:off x="6524624" y="3559248"/>
+            <a:ext cx="4629149" cy="161583"/>
           </a:xfrm>
           <a:prstGeom prst="rect">
             <a:avLst/>
@@ -6076,6 +6281,7 @@
               </a:defRPr>
             </a:pPr>
             <a:r>
+              <a:rPr sz="1050"/>
               <a:t>✅ Private key never transmitted</a:t>
             </a:r>
           </a:p>
@@ -6089,8 +6295,8 @@
         </p:nvSpPr>
         <p:spPr>
           <a:xfrm>
-            <a:off x="6524624" y="3833812"/>
-            <a:ext cx="4629149" cy="476250"/>
+            <a:off x="6524624" y="3940248"/>
+            <a:ext cx="4629149" cy="161583"/>
           </a:xfrm>
           <a:prstGeom prst="rect">
             <a:avLst/>
@@ -6111,6 +6317,7 @@
               </a:defRPr>
             </a:pPr>
             <a:r>
+              <a:rPr sz="1050"/>
               <a:t>❌ Slow — can't encrypt files</a:t>
             </a:r>
           </a:p>
@@ -6124,8 +6331,8 @@
         </p:nvSpPr>
         <p:spPr>
           <a:xfrm>
-            <a:off x="6524624" y="4214812"/>
-            <a:ext cx="4629149" cy="471487"/>
+            <a:off x="6524624" y="4321248"/>
+            <a:ext cx="4629149" cy="161583"/>
           </a:xfrm>
           <a:prstGeom prst="rect">
             <a:avLst/>
@@ -6146,6 +6353,7 @@
               </a:defRPr>
             </a:pPr>
             <a:r>
+              <a:rPr sz="1050"/>
               <a:t>❌ Limited data size (~214 bytes)</a:t>
             </a:r>
           </a:p>
@@ -6159,8 +6367,8 @@
         </p:nvSpPr>
         <p:spPr>
           <a:xfrm>
-            <a:off x="1505396" y="5295900"/>
-            <a:ext cx="1081236" cy="466725"/>
+            <a:off x="1505396" y="5402336"/>
+            <a:ext cx="1081236" cy="161583"/>
           </a:xfrm>
           <a:prstGeom prst="rect">
             <a:avLst/>
@@ -6181,6 +6389,7 @@
               </a:defRPr>
             </a:pPr>
             <a:r>
+              <a:rPr sz="1050"/>
               <a:t>📄 File Data</a:t>
             </a:r>
           </a:p>
@@ -6229,8 +6438,8 @@
         </p:nvSpPr>
         <p:spPr>
           <a:xfrm>
-            <a:off x="2929532" y="5300662"/>
-            <a:ext cx="1393179" cy="457200"/>
+            <a:off x="2929532" y="5407098"/>
+            <a:ext cx="1393179" cy="161583"/>
           </a:xfrm>
           <a:prstGeom prst="rect">
             <a:avLst/>
@@ -6251,6 +6460,7 @@
               </a:defRPr>
             </a:pPr>
             <a:r>
+              <a:rPr sz="1050" dirty="0"/>
               <a:t>AES-256 Encrypt</a:t>
             </a:r>
           </a:p>
@@ -6299,8 +6509,8 @@
         </p:nvSpPr>
         <p:spPr>
           <a:xfrm>
-            <a:off x="4665612" y="5295900"/>
-            <a:ext cx="1193899" cy="466725"/>
+            <a:off x="4665612" y="5402336"/>
+            <a:ext cx="1193899" cy="161583"/>
           </a:xfrm>
           <a:prstGeom prst="rect">
             <a:avLst/>
@@ -6321,6 +6531,7 @@
               </a:defRPr>
             </a:pPr>
             <a:r>
+              <a:rPr sz="1050" dirty="0"/>
               <a:t>🔒 Ciphertext</a:t>
             </a:r>
           </a:p>
@@ -6369,8 +6580,8 @@
         </p:nvSpPr>
         <p:spPr>
           <a:xfrm>
-            <a:off x="6227712" y="5295900"/>
-            <a:ext cx="1019770" cy="466725"/>
+            <a:off x="6227712" y="5402336"/>
+            <a:ext cx="1019770" cy="161583"/>
           </a:xfrm>
           <a:prstGeom prst="rect">
             <a:avLst/>
@@ -6391,6 +6602,7 @@
               </a:defRPr>
             </a:pPr>
             <a:r>
+              <a:rPr sz="1050"/>
               <a:t>🗝 AES Key</a:t>
             </a:r>
           </a:p>
@@ -6439,8 +6651,8 @@
         </p:nvSpPr>
         <p:spPr>
           <a:xfrm>
-            <a:off x="7590382" y="5300662"/>
-            <a:ext cx="1482030" cy="457200"/>
+            <a:off x="7590382" y="5407098"/>
+            <a:ext cx="1482030" cy="161583"/>
           </a:xfrm>
           <a:prstGeom prst="rect">
             <a:avLst/>
@@ -6461,6 +6673,7 @@
               </a:defRPr>
             </a:pPr>
             <a:r>
+              <a:rPr sz="1050"/>
               <a:t>RSA-2048 Encrypt</a:t>
             </a:r>
           </a:p>
@@ -6509,8 +6722,8 @@
         </p:nvSpPr>
         <p:spPr>
           <a:xfrm>
-            <a:off x="9415312" y="5295900"/>
-            <a:ext cx="1271140" cy="466725"/>
+            <a:off x="9415312" y="5402336"/>
+            <a:ext cx="1271140" cy="161583"/>
           </a:xfrm>
           <a:prstGeom prst="rect">
             <a:avLst/>
@@ -6531,6 +6744,7 @@
               </a:defRPr>
             </a:pPr>
             <a:r>
+              <a:rPr sz="1050"/>
               <a:t>📦 .enc Bundle</a:t>
             </a:r>
           </a:p>
@@ -6545,7 +6759,7 @@
 </file>
 
 <file path=ppt/slides/slide4.xml><?xml version="1.0" encoding="utf-8"?>
-<p:sld xmlns:a="http://schemas.openxmlformats.org/drawingml/2006/main" xmlns:p="http://schemas.openxmlformats.org/presentationml/2006/main" xmlns:r="http://schemas.openxmlformats.org/officeDocument/2006/relationships">
+<p:sld xmlns:a="http://schemas.openxmlformats.org/drawingml/2006/main" xmlns:r="http://schemas.openxmlformats.org/officeDocument/2006/relationships" xmlns:p="http://schemas.openxmlformats.org/presentationml/2006/main">
   <p:cSld>
     <p:spTree>
       <p:nvGrpSpPr>
@@ -6553,7 +6767,14 @@
         <p:cNvGrpSpPr/>
         <p:nvPr/>
       </p:nvGrpSpPr>
-      <p:grpSpPr/>
+      <p:grpSpPr>
+        <a:xfrm>
+          <a:off x="0" y="0"/>
+          <a:ext cx="0" cy="0"/>
+          <a:chOff x="0" y="0"/>
+          <a:chExt cx="0" cy="0"/>
+        </a:xfrm>
+      </p:grpSpPr>
       <p:pic>
         <p:nvPicPr>
           <p:cNvPr id="2" name="Picture 1" descr="bg_1.png"/>
@@ -6682,7 +6903,7 @@
         </p:nvSpPr>
         <p:spPr>
           <a:xfrm>
-            <a:off x="761999" y="1006375"/>
+            <a:off x="984551" y="1054756"/>
             <a:ext cx="1297483" cy="333375"/>
           </a:xfrm>
           <a:prstGeom prst="rect">
@@ -6704,6 +6925,7 @@
               </a:defRPr>
             </a:pPr>
             <a:r>
+              <a:rPr dirty="0"/>
               <a:t>METHODOLOGY</a:t>
             </a:r>
           </a:p>
@@ -6752,8 +6974,8 @@
         </p:nvSpPr>
         <p:spPr>
           <a:xfrm>
-            <a:off x="766762" y="2125563"/>
-            <a:ext cx="1622226" cy="490537"/>
+            <a:off x="940932" y="2225575"/>
+            <a:ext cx="1622226" cy="161583"/>
           </a:xfrm>
           <a:prstGeom prst="rect">
             <a:avLst/>
@@ -6774,6 +6996,7 @@
               </a:defRPr>
             </a:pPr>
             <a:r>
+              <a:rPr sz="1050"/>
               <a:t>Algorithm</a:t>
             </a:r>
           </a:p>
@@ -6787,8 +7010,8 @@
         </p:nvSpPr>
         <p:spPr>
           <a:xfrm>
-            <a:off x="2388988" y="2125563"/>
-            <a:ext cx="2039838" cy="490537"/>
+            <a:off x="2563158" y="2225575"/>
+            <a:ext cx="2039838" cy="161583"/>
           </a:xfrm>
           <a:prstGeom prst="rect">
             <a:avLst/>
@@ -6809,6 +7032,7 @@
               </a:defRPr>
             </a:pPr>
             <a:r>
+              <a:rPr sz="1050"/>
               <a:t>Type</a:t>
             </a:r>
           </a:p>
@@ -6822,8 +7046,8 @@
         </p:nvSpPr>
         <p:spPr>
           <a:xfrm>
-            <a:off x="4428826" y="2125563"/>
-            <a:ext cx="1642020" cy="490537"/>
+            <a:off x="4602996" y="2225575"/>
+            <a:ext cx="1642020" cy="161583"/>
           </a:xfrm>
           <a:prstGeom prst="rect">
             <a:avLst/>
@@ -6844,6 +7068,7 @@
               </a:defRPr>
             </a:pPr>
             <a:r>
+              <a:rPr sz="1050"/>
               <a:t>Key Size</a:t>
             </a:r>
           </a:p>
@@ -6857,8 +7082,8 @@
         </p:nvSpPr>
         <p:spPr>
           <a:xfrm>
-            <a:off x="6070847" y="2125563"/>
-            <a:ext cx="2263824" cy="490537"/>
+            <a:off x="6245017" y="2225575"/>
+            <a:ext cx="2263824" cy="161583"/>
           </a:xfrm>
           <a:prstGeom prst="rect">
             <a:avLst/>
@@ -6879,6 +7104,7 @@
               </a:defRPr>
             </a:pPr>
             <a:r>
+              <a:rPr sz="1050"/>
               <a:t>Mode/Variant</a:t>
             </a:r>
           </a:p>
@@ -6892,8 +7118,8 @@
         </p:nvSpPr>
         <p:spPr>
           <a:xfrm>
-            <a:off x="8334671" y="2125563"/>
-            <a:ext cx="3090564" cy="490537"/>
+            <a:off x="8508841" y="2225575"/>
+            <a:ext cx="3090564" cy="161583"/>
           </a:xfrm>
           <a:prstGeom prst="rect">
             <a:avLst/>
@@ -6914,6 +7140,7 @@
               </a:defRPr>
             </a:pPr>
             <a:r>
+              <a:rPr sz="1050"/>
               <a:t>Purpose</a:t>
             </a:r>
           </a:p>
@@ -6927,8 +7154,8 @@
         </p:nvSpPr>
         <p:spPr>
           <a:xfrm>
-            <a:off x="766762" y="2520850"/>
-            <a:ext cx="1622226" cy="461962"/>
+            <a:off x="940932" y="2620862"/>
+            <a:ext cx="1622226" cy="161583"/>
           </a:xfrm>
           <a:prstGeom prst="rect">
             <a:avLst/>
@@ -6949,6 +7176,7 @@
               </a:defRPr>
             </a:pPr>
             <a:r>
+              <a:rPr sz="1050"/>
               <a:t>AES</a:t>
             </a:r>
           </a:p>
@@ -6962,8 +7190,8 @@
         </p:nvSpPr>
         <p:spPr>
           <a:xfrm>
-            <a:off x="2388988" y="2520850"/>
-            <a:ext cx="2039838" cy="461962"/>
+            <a:off x="2563158" y="2620862"/>
+            <a:ext cx="2039838" cy="161583"/>
           </a:xfrm>
           <a:prstGeom prst="rect">
             <a:avLst/>
@@ -6984,6 +7212,7 @@
               </a:defRPr>
             </a:pPr>
             <a:r>
+              <a:rPr sz="1050"/>
               <a:t>Symmetric</a:t>
             </a:r>
           </a:p>
@@ -6997,8 +7226,8 @@
         </p:nvSpPr>
         <p:spPr>
           <a:xfrm>
-            <a:off x="4428826" y="2520850"/>
-            <a:ext cx="1642020" cy="461962"/>
+            <a:off x="4602996" y="2620862"/>
+            <a:ext cx="1642020" cy="161583"/>
           </a:xfrm>
           <a:prstGeom prst="rect">
             <a:avLst/>
@@ -7019,6 +7248,7 @@
               </a:defRPr>
             </a:pPr>
             <a:r>
+              <a:rPr sz="1050"/>
               <a:t>256-bit</a:t>
             </a:r>
           </a:p>
@@ -7032,8 +7262,8 @@
         </p:nvSpPr>
         <p:spPr>
           <a:xfrm>
-            <a:off x="6070847" y="2520850"/>
-            <a:ext cx="2263824" cy="461962"/>
+            <a:off x="6245017" y="2620862"/>
+            <a:ext cx="2263824" cy="161583"/>
           </a:xfrm>
           <a:prstGeom prst="rect">
             <a:avLst/>
@@ -7054,6 +7284,7 @@
               </a:defRPr>
             </a:pPr>
             <a:r>
+              <a:rPr sz="1050"/>
               <a:t>CBC + PKCS7</a:t>
             </a:r>
           </a:p>
@@ -7067,8 +7298,8 @@
         </p:nvSpPr>
         <p:spPr>
           <a:xfrm>
-            <a:off x="8334671" y="2520850"/>
-            <a:ext cx="3090564" cy="461962"/>
+            <a:off x="8508841" y="2620862"/>
+            <a:ext cx="3090564" cy="161583"/>
           </a:xfrm>
           <a:prstGeom prst="rect">
             <a:avLst/>
@@ -7089,6 +7320,7 @@
               </a:defRPr>
             </a:pPr>
             <a:r>
+              <a:rPr sz="1050"/>
               <a:t>Encrypt file content (fast)</a:t>
             </a:r>
           </a:p>
@@ -7102,8 +7334,8 @@
         </p:nvSpPr>
         <p:spPr>
           <a:xfrm>
-            <a:off x="766762" y="2887563"/>
-            <a:ext cx="1622226" cy="466725"/>
+            <a:off x="940932" y="2987575"/>
+            <a:ext cx="1622226" cy="161583"/>
           </a:xfrm>
           <a:prstGeom prst="rect">
             <a:avLst/>
@@ -7124,6 +7356,7 @@
               </a:defRPr>
             </a:pPr>
             <a:r>
+              <a:rPr sz="1050"/>
               <a:t>RSA</a:t>
             </a:r>
           </a:p>
@@ -7137,8 +7370,8 @@
         </p:nvSpPr>
         <p:spPr>
           <a:xfrm>
-            <a:off x="2388988" y="2887563"/>
-            <a:ext cx="2039838" cy="466725"/>
+            <a:off x="2563158" y="2987575"/>
+            <a:ext cx="2039838" cy="161583"/>
           </a:xfrm>
           <a:prstGeom prst="rect">
             <a:avLst/>
@@ -7159,6 +7392,7 @@
               </a:defRPr>
             </a:pPr>
             <a:r>
+              <a:rPr sz="1050"/>
               <a:t>Asymmetric</a:t>
             </a:r>
           </a:p>
@@ -7172,8 +7406,8 @@
         </p:nvSpPr>
         <p:spPr>
           <a:xfrm>
-            <a:off x="4428826" y="2887563"/>
-            <a:ext cx="1642020" cy="466725"/>
+            <a:off x="4602996" y="2987575"/>
+            <a:ext cx="1642020" cy="161583"/>
           </a:xfrm>
           <a:prstGeom prst="rect">
             <a:avLst/>
@@ -7194,6 +7428,7 @@
               </a:defRPr>
             </a:pPr>
             <a:r>
+              <a:rPr sz="1050"/>
               <a:t>2048-bit</a:t>
             </a:r>
           </a:p>
@@ -7207,8 +7442,8 @@
         </p:nvSpPr>
         <p:spPr>
           <a:xfrm>
-            <a:off x="6070847" y="2887563"/>
-            <a:ext cx="2263824" cy="466725"/>
+            <a:off x="6245017" y="2987575"/>
+            <a:ext cx="2263824" cy="161583"/>
           </a:xfrm>
           <a:prstGeom prst="rect">
             <a:avLst/>
@@ -7229,6 +7464,7 @@
               </a:defRPr>
             </a:pPr>
             <a:r>
+              <a:rPr sz="1050"/>
               <a:t>OAEP + SHA-256</a:t>
             </a:r>
           </a:p>
@@ -7242,8 +7478,8 @@
         </p:nvSpPr>
         <p:spPr>
           <a:xfrm>
-            <a:off x="8334671" y="2887563"/>
-            <a:ext cx="3090564" cy="466725"/>
+            <a:off x="8508841" y="2987575"/>
+            <a:ext cx="3090564" cy="161583"/>
           </a:xfrm>
           <a:prstGeom prst="rect">
             <a:avLst/>
@@ -7264,6 +7500,7 @@
               </a:defRPr>
             </a:pPr>
             <a:r>
+              <a:rPr sz="1050"/>
               <a:t>Encrypt AES session key</a:t>
             </a:r>
           </a:p>
@@ -7277,8 +7514,8 @@
         </p:nvSpPr>
         <p:spPr>
           <a:xfrm>
-            <a:off x="766762" y="3259038"/>
-            <a:ext cx="1622226" cy="466725"/>
+            <a:off x="940932" y="3359050"/>
+            <a:ext cx="1622226" cy="161583"/>
           </a:xfrm>
           <a:prstGeom prst="rect">
             <a:avLst/>
@@ -7299,6 +7536,7 @@
               </a:defRPr>
             </a:pPr>
             <a:r>
+              <a:rPr sz="1050"/>
               <a:t>HMAC</a:t>
             </a:r>
           </a:p>
@@ -7312,8 +7550,8 @@
         </p:nvSpPr>
         <p:spPr>
           <a:xfrm>
-            <a:off x="2388988" y="3259038"/>
-            <a:ext cx="2039838" cy="466725"/>
+            <a:off x="2563158" y="3359050"/>
+            <a:ext cx="2039838" cy="161583"/>
           </a:xfrm>
           <a:prstGeom prst="rect">
             <a:avLst/>
@@ -7334,6 +7572,7 @@
               </a:defRPr>
             </a:pPr>
             <a:r>
+              <a:rPr sz="1050"/>
               <a:t>MAC / Integrity</a:t>
             </a:r>
           </a:p>
@@ -7347,8 +7586,8 @@
         </p:nvSpPr>
         <p:spPr>
           <a:xfrm>
-            <a:off x="4428826" y="3259038"/>
-            <a:ext cx="1642020" cy="466725"/>
+            <a:off x="4602996" y="3359050"/>
+            <a:ext cx="1642020" cy="161583"/>
           </a:xfrm>
           <a:prstGeom prst="rect">
             <a:avLst/>
@@ -7369,6 +7608,7 @@
               </a:defRPr>
             </a:pPr>
             <a:r>
+              <a:rPr sz="1050"/>
               <a:t>256-bit tag</a:t>
             </a:r>
           </a:p>
@@ -7382,8 +7622,8 @@
         </p:nvSpPr>
         <p:spPr>
           <a:xfrm>
-            <a:off x="6070847" y="3259038"/>
-            <a:ext cx="2263824" cy="466725"/>
+            <a:off x="6245017" y="3359050"/>
+            <a:ext cx="2263824" cy="161583"/>
           </a:xfrm>
           <a:prstGeom prst="rect">
             <a:avLst/>
@@ -7404,6 +7644,7 @@
               </a:defRPr>
             </a:pPr>
             <a:r>
+              <a:rPr sz="1050"/>
               <a:t>SHA-256</a:t>
             </a:r>
           </a:p>
@@ -7417,8 +7658,8 @@
         </p:nvSpPr>
         <p:spPr>
           <a:xfrm>
-            <a:off x="8334671" y="3259038"/>
-            <a:ext cx="3090564" cy="466725"/>
+            <a:off x="8508841" y="3359050"/>
+            <a:ext cx="3090564" cy="161583"/>
           </a:xfrm>
           <a:prstGeom prst="rect">
             <a:avLst/>
@@ -7439,6 +7680,7 @@
               </a:defRPr>
             </a:pPr>
             <a:r>
+              <a:rPr sz="1050"/>
               <a:t>Detect tampering</a:t>
             </a:r>
           </a:p>
@@ -7452,8 +7694,8 @@
         </p:nvSpPr>
         <p:spPr>
           <a:xfrm>
-            <a:off x="766762" y="3630513"/>
-            <a:ext cx="1622226" cy="466725"/>
+            <a:off x="940932" y="3730525"/>
+            <a:ext cx="1622226" cy="161583"/>
           </a:xfrm>
           <a:prstGeom prst="rect">
             <a:avLst/>
@@ -7474,6 +7716,7 @@
               </a:defRPr>
             </a:pPr>
             <a:r>
+              <a:rPr sz="1050"/>
               <a:t>IV</a:t>
             </a:r>
           </a:p>
@@ -7487,8 +7730,8 @@
         </p:nvSpPr>
         <p:spPr>
           <a:xfrm>
-            <a:off x="2388988" y="3630513"/>
-            <a:ext cx="2039838" cy="466725"/>
+            <a:off x="2563158" y="3730525"/>
+            <a:ext cx="2039838" cy="161583"/>
           </a:xfrm>
           <a:prstGeom prst="rect">
             <a:avLst/>
@@ -7509,6 +7752,7 @@
               </a:defRPr>
             </a:pPr>
             <a:r>
+              <a:rPr sz="1050"/>
               <a:t>Randomness</a:t>
             </a:r>
           </a:p>
@@ -7522,8 +7766,8 @@
         </p:nvSpPr>
         <p:spPr>
           <a:xfrm>
-            <a:off x="4428826" y="3630513"/>
-            <a:ext cx="1642020" cy="466725"/>
+            <a:off x="4602996" y="3730525"/>
+            <a:ext cx="1642020" cy="161583"/>
           </a:xfrm>
           <a:prstGeom prst="rect">
             <a:avLst/>
@@ -7544,6 +7788,7 @@
               </a:defRPr>
             </a:pPr>
             <a:r>
+              <a:rPr sz="1050"/>
               <a:t>128-bit</a:t>
             </a:r>
           </a:p>
@@ -7557,8 +7802,8 @@
         </p:nvSpPr>
         <p:spPr>
           <a:xfrm>
-            <a:off x="6070847" y="3630513"/>
-            <a:ext cx="2263824" cy="466725"/>
+            <a:off x="6245017" y="3730525"/>
+            <a:ext cx="2263824" cy="161583"/>
           </a:xfrm>
           <a:prstGeom prst="rect">
             <a:avLst/>
@@ -7579,6 +7824,7 @@
               </a:defRPr>
             </a:pPr>
             <a:r>
+              <a:rPr sz="1050"/>
               <a:t>CSPRNG</a:t>
             </a:r>
           </a:p>
@@ -7592,8 +7838,8 @@
         </p:nvSpPr>
         <p:spPr>
           <a:xfrm>
-            <a:off x="8334671" y="3630513"/>
-            <a:ext cx="3090564" cy="466725"/>
+            <a:off x="8508841" y="3730525"/>
+            <a:ext cx="3090564" cy="161583"/>
           </a:xfrm>
           <a:prstGeom prst="rect">
             <a:avLst/>
@@ -7614,6 +7860,7 @@
               </a:defRPr>
             </a:pPr>
             <a:r>
+              <a:rPr sz="1050"/>
               <a:t>Prevent pattern leakage</a:t>
             </a:r>
           </a:p>
@@ -7663,7 +7910,7 @@
         <p:spPr>
           <a:xfrm>
             <a:off x="1038224" y="4787800"/>
-            <a:ext cx="4629149" cy="920799"/>
+            <a:ext cx="4629149" cy="646331"/>
           </a:xfrm>
           <a:prstGeom prst="rect">
             <a:avLst/>
@@ -7684,6 +7931,7 @@
               </a:defRPr>
             </a:pPr>
             <a:r>
+              <a:rPr sz="1400" dirty="0"/>
               <a:t>Optimal Asymmetric Encryption Padding adds randomness to RSA, preventing deterministic outputs and chosen-ciphertext attacks</a:t>
             </a:r>
           </a:p>
@@ -7733,7 +7981,7 @@
         <p:spPr>
           <a:xfrm>
             <a:off x="6524624" y="4787800"/>
-            <a:ext cx="4629149" cy="920799"/>
+            <a:ext cx="4629149" cy="646331"/>
           </a:xfrm>
           <a:prstGeom prst="rect">
             <a:avLst/>
@@ -7754,6 +8002,7 @@
               </a:defRPr>
             </a:pPr>
             <a:r>
+              <a:rPr sz="1400"/>
               <a:t>HMAC is computed over ciphertext after encryption — provably secure ordering that detects tampering before decryption begins</a:t>
             </a:r>
           </a:p>
@@ -7768,7 +8017,7 @@
 </file>
 
 <file path=ppt/slides/slide5.xml><?xml version="1.0" encoding="utf-8"?>
-<p:sld xmlns:a="http://schemas.openxmlformats.org/drawingml/2006/main" xmlns:p="http://schemas.openxmlformats.org/presentationml/2006/main" xmlns:r="http://schemas.openxmlformats.org/officeDocument/2006/relationships">
+<p:sld xmlns:a="http://schemas.openxmlformats.org/drawingml/2006/main" xmlns:r="http://schemas.openxmlformats.org/officeDocument/2006/relationships" xmlns:p="http://schemas.openxmlformats.org/presentationml/2006/main">
   <p:cSld>
     <p:spTree>
       <p:nvGrpSpPr>
@@ -7776,7 +8025,14 @@
         <p:cNvGrpSpPr/>
         <p:nvPr/>
       </p:nvGrpSpPr>
-      <p:grpSpPr/>
+      <p:grpSpPr>
+        <a:xfrm>
+          <a:off x="0" y="0"/>
+          <a:ext cx="0" cy="0"/>
+          <a:chOff x="0" y="0"/>
+          <a:chExt cx="0" cy="0"/>
+        </a:xfrm>
+      </p:grpSpPr>
       <p:pic>
         <p:nvPicPr>
           <p:cNvPr id="2" name="Picture 1" descr="bg_1.png"/>
@@ -8001,7 +8257,7 @@
         </p:nvSpPr>
         <p:spPr>
           <a:xfrm>
-            <a:off x="761999" y="603795"/>
+            <a:off x="984547" y="637662"/>
             <a:ext cx="1445567" cy="333375"/>
           </a:xfrm>
           <a:prstGeom prst="rect">
@@ -8023,6 +8279,7 @@
               </a:defRPr>
             </a:pPr>
             <a:r>
+              <a:rPr dirty="0"/>
               <a:t>IMPLEMENTATION</a:t>
             </a:r>
           </a:p>
@@ -8141,21 +8398,21 @@
         </p:nvSpPr>
         <p:spPr>
           <a:xfrm>
-            <a:off x="6248399" y="2146845"/>
-            <a:ext cx="5181599" cy="3298626"/>
-          </a:xfrm>
-          <a:prstGeom prst="rect">
-            <a:avLst/>
-          </a:prstGeom>
-          <a:noFill/>
-        </p:spPr>
-        <p:txBody>
-          <a:bodyPr wrap="square" lIns="0" tIns="0" rIns="0" bIns="0">
-            <a:spAutoFit/>
-          </a:bodyPr>
-          <a:lstStyle/>
-          <a:p>
-            <a:pPr algn="l">
+            <a:off x="6248398" y="2406758"/>
+            <a:ext cx="5181599" cy="2585323"/>
+          </a:xfrm>
+          <a:prstGeom prst="rect">
+            <a:avLst/>
+          </a:prstGeom>
+          <a:noFill/>
+        </p:spPr>
+        <p:txBody>
+          <a:bodyPr wrap="square" lIns="0" tIns="0" rIns="0" bIns="0">
+            <a:spAutoFit/>
+          </a:bodyPr>
+          <a:lstStyle/>
+          <a:p>
+            <a:pPr algn="ctr">
               <a:defRPr sz="900">
                 <a:solidFill>
                   <a:srgbClr val="E6EDF3"/>
@@ -8163,58 +8420,98 @@
               </a:defRPr>
             </a:pPr>
             <a:r>
+              <a:rPr sz="1200" dirty="0"/>
               <a:t>┌─────────────────────────────┐</a:t>
             </a:r>
-            <a:br/>
-            <a:r>
+            <a:br>
+              <a:rPr sz="1200" dirty="0"/>
+            </a:br>
+            <a:r>
+              <a:rPr sz="1200" dirty="0"/>
               <a:t>│  MAGIC HEADER   (8 bytes)  │</a:t>
             </a:r>
-            <a:br/>
-            <a:r>
+            <a:br>
+              <a:rPr sz="1200" dirty="0"/>
+            </a:br>
+            <a:r>
+              <a:rPr sz="1200" dirty="0"/>
               <a:t>├─────────────────────────────┤</a:t>
             </a:r>
-            <a:br/>
-            <a:r>
+            <a:br>
+              <a:rPr sz="1200" dirty="0"/>
+            </a:br>
+            <a:r>
+              <a:rPr sz="1200" dirty="0"/>
               <a:t>│  KEY LENGTH     (2 bytes)  │</a:t>
             </a:r>
-            <a:br/>
-            <a:r>
+            <a:br>
+              <a:rPr sz="1200" dirty="0"/>
+            </a:br>
+            <a:r>
+              <a:rPr sz="1200" dirty="0"/>
               <a:t>├─────────────────────────────┤</a:t>
             </a:r>
-            <a:br/>
-            <a:r>
+            <a:br>
+              <a:rPr sz="1200" dirty="0"/>
+            </a:br>
+            <a:r>
+              <a:rPr sz="1200" dirty="0"/>
               <a:t>│  RSA-ENCRYPTED AES KEY     │</a:t>
             </a:r>
-            <a:br/>
-            <a:r>
+            <a:br>
+              <a:rPr sz="1200" dirty="0"/>
+            </a:br>
+            <a:r>
+              <a:rPr sz="1200" dirty="0"/>
               <a:t>│  (256 bytes for 2048-bit)  │</a:t>
             </a:r>
-            <a:br/>
-            <a:r>
+            <a:br>
+              <a:rPr sz="1200" dirty="0"/>
+            </a:br>
+            <a:r>
+              <a:rPr sz="1200" dirty="0"/>
               <a:t>├─────────────────────────────┤</a:t>
             </a:r>
-            <a:br/>
-            <a:r>
+            <a:br>
+              <a:rPr sz="1200" dirty="0"/>
+            </a:br>
+            <a:r>
+              <a:rPr sz="1200" dirty="0"/>
               <a:t>│  AES IV         (16 bytes) │</a:t>
             </a:r>
-            <a:br/>
-            <a:r>
+            <a:br>
+              <a:rPr sz="1200" dirty="0"/>
+            </a:br>
+            <a:r>
+              <a:rPr sz="1200" dirty="0"/>
               <a:t>├─────────────────────────────┤</a:t>
             </a:r>
-            <a:br/>
-            <a:r>
+            <a:br>
+              <a:rPr sz="1200" dirty="0"/>
+            </a:br>
+            <a:r>
+              <a:rPr sz="1200" dirty="0"/>
               <a:t>│  HMAC-SHA256    (32 bytes) │</a:t>
             </a:r>
-            <a:br/>
-            <a:r>
+            <a:br>
+              <a:rPr sz="1200" dirty="0"/>
+            </a:br>
+            <a:r>
+              <a:rPr sz="1200" dirty="0"/>
               <a:t>├─────────────────────────────┤</a:t>
             </a:r>
-            <a:br/>
-            <a:r>
+            <a:br>
+              <a:rPr sz="1200" dirty="0"/>
+            </a:br>
+            <a:r>
+              <a:rPr sz="1200" dirty="0"/>
               <a:t>│  CIPHERTEXT     (variable) │</a:t>
             </a:r>
-            <a:br/>
-            <a:r>
+            <a:br>
+              <a:rPr sz="1200" dirty="0"/>
+            </a:br>
+            <a:r>
+              <a:rPr sz="1200" dirty="0"/>
               <a:t>└─────────────────────────────┘</a:t>
             </a:r>
           </a:p>
@@ -8264,7 +8561,7 @@
 </file>
 
 <file path=ppt/slides/slide6.xml><?xml version="1.0" encoding="utf-8"?>
-<p:sld xmlns:a="http://schemas.openxmlformats.org/drawingml/2006/main" xmlns:p="http://schemas.openxmlformats.org/presentationml/2006/main" xmlns:r="http://schemas.openxmlformats.org/officeDocument/2006/relationships">
+<p:sld xmlns:a="http://schemas.openxmlformats.org/drawingml/2006/main" xmlns:r="http://schemas.openxmlformats.org/officeDocument/2006/relationships" xmlns:p="http://schemas.openxmlformats.org/presentationml/2006/main">
   <p:cSld>
     <p:spTree>
       <p:nvGrpSpPr>
@@ -8272,7 +8569,14 @@
         <p:cNvGrpSpPr/>
         <p:nvPr/>
       </p:nvGrpSpPr>
-      <p:grpSpPr/>
+      <p:grpSpPr>
+        <a:xfrm>
+          <a:off x="0" y="0"/>
+          <a:ext cx="0" cy="0"/>
+          <a:chOff x="0" y="0"/>
+          <a:chExt cx="0" cy="0"/>
+        </a:xfrm>
+      </p:grpSpPr>
       <p:pic>
         <p:nvPicPr>
           <p:cNvPr id="2" name="Picture 1" descr="bg_1.png"/>
@@ -8401,21 +8705,21 @@
         </p:nvSpPr>
         <p:spPr>
           <a:xfrm>
-            <a:off x="761999" y="640853"/>
-            <a:ext cx="647699" cy="333375"/>
-          </a:xfrm>
-          <a:prstGeom prst="rect">
-            <a:avLst/>
-          </a:prstGeom>
-          <a:noFill/>
-        </p:spPr>
-        <p:txBody>
-          <a:bodyPr wrap="square" lIns="0" tIns="0" rIns="0" bIns="0">
-            <a:spAutoFit/>
-          </a:bodyPr>
-          <a:lstStyle/>
-          <a:p>
-            <a:pPr algn="l">
+            <a:off x="761999" y="694071"/>
+            <a:ext cx="647699" cy="138499"/>
+          </a:xfrm>
+          <a:prstGeom prst="rect">
+            <a:avLst/>
+          </a:prstGeom>
+          <a:noFill/>
+        </p:spPr>
+        <p:txBody>
+          <a:bodyPr wrap="square" lIns="0" tIns="0" rIns="0" bIns="0">
+            <a:spAutoFit/>
+          </a:bodyPr>
+          <a:lstStyle/>
+          <a:p>
+            <a:pPr algn="ctr">
               <a:defRPr sz="900" b="1">
                 <a:solidFill>
                   <a:srgbClr val="BC8CFF"/>
@@ -8423,6 +8727,7 @@
               </a:defRPr>
             </a:pPr>
             <a:r>
+              <a:rPr dirty="0"/>
               <a:t>CODE</a:t>
             </a:r>
           </a:p>
@@ -8471,21 +8776,21 @@
         </p:nvSpPr>
         <p:spPr>
           <a:xfrm>
-            <a:off x="761999" y="1755278"/>
-            <a:ext cx="5181599" cy="4557117"/>
-          </a:xfrm>
-          <a:prstGeom prst="rect">
-            <a:avLst/>
-          </a:prstGeom>
-          <a:noFill/>
-        </p:spPr>
-        <p:txBody>
-          <a:bodyPr wrap="square" lIns="0" tIns="0" rIns="0" bIns="0">
-            <a:spAutoFit/>
-          </a:bodyPr>
-          <a:lstStyle/>
-          <a:p>
-            <a:pPr algn="l">
+            <a:off x="1038224" y="2032693"/>
+            <a:ext cx="5181599" cy="3693319"/>
+          </a:xfrm>
+          <a:prstGeom prst="rect">
+            <a:avLst/>
+          </a:prstGeom>
+          <a:noFill/>
+        </p:spPr>
+        <p:txBody>
+          <a:bodyPr wrap="square" lIns="0" tIns="0" rIns="0" bIns="0">
+            <a:spAutoFit/>
+          </a:bodyPr>
+          <a:lstStyle/>
+          <a:p>
+            <a:pPr>
               <a:defRPr sz="862">
                 <a:solidFill>
                   <a:srgbClr val="E6EDF3"/>
@@ -8493,59 +8798,213 @@
               </a:defRPr>
             </a:pPr>
             <a:r>
-              <a:t>Crypto.Cipher  AES, PKCS1_OAEP</a:t>
-            </a:r>
-            <a:br/>
-            <a:r>
-              <a:t> Crypto.PublicKey  RSA</a:t>
-            </a:r>
-            <a:br/>
-            <a:r>
-              <a:t> Crypto.Random  get_random_bytes</a:t>
-            </a:r>
-            <a:br/>
-            <a:br/>
-            <a:br/>
-            <a:r>
-              <a:t>aes_key = ()  </a:t>
-            </a:r>
-            <a:br/>
-            <a:r>
+              <a:rPr sz="1200" dirty="0" err="1"/>
+              <a:t>Crypto.Cipher</a:t>
+            </a:r>
+            <a:r>
+              <a:rPr sz="1200" dirty="0"/>
+              <a:t>  AES, PKCS1_OAEP</a:t>
+            </a:r>
+            <a:br>
+              <a:rPr sz="1200" dirty="0"/>
+            </a:br>
+            <a:r>
+              <a:rPr sz="1200" dirty="0"/>
+              <a:t> </a:t>
+            </a:r>
+            <a:r>
+              <a:rPr sz="1200" dirty="0" err="1"/>
+              <a:t>Crypto.PublicKey</a:t>
+            </a:r>
+            <a:r>
+              <a:rPr sz="1200" dirty="0"/>
+              <a:t>  RSA</a:t>
+            </a:r>
+            <a:br>
+              <a:rPr sz="1200" dirty="0"/>
+            </a:br>
+            <a:r>
+              <a:rPr sz="1200" dirty="0"/>
+              <a:t> </a:t>
+            </a:r>
+            <a:r>
+              <a:rPr sz="1200" dirty="0" err="1"/>
+              <a:t>Crypto.Random</a:t>
+            </a:r>
+            <a:r>
+              <a:rPr sz="1200" dirty="0"/>
+              <a:t>  </a:t>
+            </a:r>
+            <a:r>
+              <a:rPr sz="1200" dirty="0" err="1"/>
+              <a:t>get_random_bytes</a:t>
+            </a:r>
+            <a:br>
+              <a:rPr sz="1200" dirty="0"/>
+            </a:br>
+            <a:br>
+              <a:rPr sz="1200" dirty="0"/>
+            </a:br>
+            <a:br>
+              <a:rPr sz="1200" dirty="0"/>
+            </a:br>
+            <a:r>
+              <a:rPr sz="1200" dirty="0" err="1"/>
+              <a:t>aes_key</a:t>
+            </a:r>
+            <a:r>
+              <a:rPr sz="1200" dirty="0"/>
+              <a:t> = ()  </a:t>
+            </a:r>
+            <a:br>
+              <a:rPr sz="1200" dirty="0"/>
+            </a:br>
+            <a:r>
+              <a:rPr sz="1200" dirty="0"/>
               <a:t>iv      = ()  </a:t>
             </a:r>
-            <a:br/>
-            <a:br/>
-            <a:br/>
-            <a:r>
-              <a:t>cipher = AES.(aes_key, AES.MODE_CBC, iv)</a:t>
-            </a:r>
-            <a:br/>
-            <a:r>
+            <a:br>
+              <a:rPr sz="1200" dirty="0"/>
+            </a:br>
+            <a:br>
+              <a:rPr sz="1200" dirty="0"/>
+            </a:br>
+            <a:br>
+              <a:rPr sz="1200" dirty="0"/>
+            </a:br>
+            <a:r>
+              <a:rPr sz="1200" dirty="0"/>
+              <a:t>cipher = AES.(</a:t>
+            </a:r>
+            <a:r>
+              <a:rPr sz="1200" dirty="0" err="1"/>
+              <a:t>aes_key</a:t>
+            </a:r>
+            <a:r>
+              <a:rPr sz="1200" dirty="0"/>
+              <a:t>, AES.MODE_CBC, iv)</a:t>
+            </a:r>
+            <a:br>
+              <a:rPr sz="1200" dirty="0"/>
+            </a:br>
+            <a:r>
+              <a:rPr sz="1200" dirty="0"/>
               <a:t>ciphertext = cipher.((data, ))</a:t>
             </a:r>
-            <a:br/>
-            <a:br/>
-            <a:br/>
-            <a:r>
-              <a:t>mac = hmac.(aes_key, iv+ciphertext,</a:t>
-            </a:r>
-            <a:br/>
-            <a:r>
+            <a:br>
+              <a:rPr sz="1200" dirty="0"/>
+            </a:br>
+            <a:br>
+              <a:rPr sz="1200" dirty="0"/>
+            </a:br>
+            <a:br>
+              <a:rPr sz="1200" dirty="0"/>
+            </a:br>
+            <a:r>
+              <a:rPr sz="1200" dirty="0"/>
+              <a:t>mac = </a:t>
+            </a:r>
+            <a:r>
+              <a:rPr sz="1200" dirty="0" err="1"/>
+              <a:t>hmac</a:t>
+            </a:r>
+            <a:r>
+              <a:rPr sz="1200" dirty="0"/>
+              <a:t>.(</a:t>
+            </a:r>
+            <a:r>
+              <a:rPr sz="1200" dirty="0" err="1"/>
+              <a:t>aes_key</a:t>
+            </a:r>
+            <a:r>
+              <a:rPr sz="1200" dirty="0"/>
+              <a:t>, </a:t>
+            </a:r>
+            <a:r>
+              <a:rPr sz="1200" dirty="0" err="1"/>
+              <a:t>iv+ciphertext</a:t>
+            </a:r>
+            <a:r>
+              <a:rPr sz="1200" dirty="0"/>
+              <a:t>,</a:t>
+            </a:r>
+            <a:br>
+              <a:rPr sz="1200" dirty="0"/>
+            </a:br>
+            <a:r>
+              <a:rPr sz="1200" dirty="0"/>
               <a:t>              hashlib.sha256).()</a:t>
             </a:r>
-            <a:br/>
-            <a:br/>
-            <a:br/>
-            <a:r>
-              <a:t>rsa_key = RSA.(pub_pem)</a:t>
-            </a:r>
-            <a:br/>
-            <a:r>
-              <a:t>cipher_rsa = PKCS1_OAEP.(rsa_key)</a:t>
-            </a:r>
-            <a:br/>
-            <a:r>
-              <a:t>enc_key = cipher_rsa.(aes_key)</a:t>
+            <a:br>
+              <a:rPr sz="1200" dirty="0"/>
+            </a:br>
+            <a:br>
+              <a:rPr sz="1200" dirty="0"/>
+            </a:br>
+            <a:br>
+              <a:rPr sz="1200" dirty="0"/>
+            </a:br>
+            <a:r>
+              <a:rPr sz="1200" dirty="0" err="1"/>
+              <a:t>rsa_key</a:t>
+            </a:r>
+            <a:r>
+              <a:rPr sz="1200" dirty="0"/>
+              <a:t> = RSA.(</a:t>
+            </a:r>
+            <a:r>
+              <a:rPr sz="1200" dirty="0" err="1"/>
+              <a:t>pub_pem</a:t>
+            </a:r>
+            <a:r>
+              <a:rPr sz="1200" dirty="0"/>
+              <a:t>)</a:t>
+            </a:r>
+            <a:br>
+              <a:rPr sz="1200" dirty="0"/>
+            </a:br>
+            <a:r>
+              <a:rPr sz="1200" dirty="0" err="1"/>
+              <a:t>cipher_rsa</a:t>
+            </a:r>
+            <a:r>
+              <a:rPr sz="1200" dirty="0"/>
+              <a:t> = PKCS1_OAEP.(</a:t>
+            </a:r>
+            <a:r>
+              <a:rPr sz="1200" dirty="0" err="1"/>
+              <a:t>rsa_key</a:t>
+            </a:r>
+            <a:r>
+              <a:rPr sz="1200" dirty="0"/>
+              <a:t>)</a:t>
+            </a:r>
+            <a:br>
+              <a:rPr sz="1200" dirty="0"/>
+            </a:br>
+            <a:r>
+              <a:rPr sz="1200" dirty="0" err="1"/>
+              <a:t>enc_key</a:t>
+            </a:r>
+            <a:r>
+              <a:rPr sz="1200" dirty="0"/>
+              <a:t> = </a:t>
+            </a:r>
+            <a:r>
+              <a:rPr sz="1200" dirty="0" err="1"/>
+              <a:t>cipher_rsa</a:t>
+            </a:r>
+            <a:r>
+              <a:rPr sz="1200" dirty="0"/>
+              <a:t>.(</a:t>
+            </a:r>
+            <a:r>
+              <a:rPr sz="1200" dirty="0" err="1"/>
+              <a:t>aes_key</a:t>
+            </a:r>
+            <a:r>
+              <a:rPr sz="1200" dirty="0"/>
+              <a:t>)</a:t>
             </a:r>
           </a:p>
         </p:txBody>
@@ -8593,8 +9052,8 @@
         </p:nvSpPr>
         <p:spPr>
           <a:xfrm>
-            <a:off x="6524624" y="2345828"/>
-            <a:ext cx="4629149" cy="1238250"/>
+            <a:off x="6524624" y="2360342"/>
+            <a:ext cx="4629149" cy="923330"/>
           </a:xfrm>
           <a:prstGeom prst="rect">
             <a:avLst/>
@@ -8615,22 +9074,35 @@
               </a:defRPr>
             </a:pPr>
             <a:r>
+              <a:rPr sz="1200"/>
               <a:t>app.py           ← PyQt6 desktop app </a:t>
             </a:r>
-            <a:br/>
-            <a:r>
+            <a:br>
+              <a:rPr sz="1200"/>
+            </a:br>
+            <a:r>
+              <a:rPr sz="1200"/>
               <a:t>            hybrid_crypto.py ← Core engine</a:t>
             </a:r>
-            <a:br/>
-            <a:r>
+            <a:br>
+              <a:rPr sz="1200"/>
+            </a:br>
+            <a:r>
+              <a:rPr sz="1200"/>
               <a:t>            cli.py           ← Terminal CLI</a:t>
             </a:r>
-            <a:br/>
-            <a:r>
+            <a:br>
+              <a:rPr sz="1200"/>
+            </a:br>
+            <a:r>
+              <a:rPr sz="1200"/>
               <a:t>            test_crypto.py   ← 10 tests (all pass)</a:t>
             </a:r>
-            <a:br/>
-            <a:r>
+            <a:br>
+              <a:rPr sz="1200"/>
+            </a:br>
+            <a:r>
+              <a:rPr sz="1200"/>
               <a:t>            dist/HybridCrypto.exe ← Standalone .exe</a:t>
             </a:r>
           </a:p>
@@ -8679,8 +9151,8 @@
         </p:nvSpPr>
         <p:spPr>
           <a:xfrm>
-            <a:off x="6524624" y="4469903"/>
-            <a:ext cx="4629149" cy="1085850"/>
+            <a:off x="6524624" y="4484417"/>
+            <a:ext cx="4629149" cy="738664"/>
           </a:xfrm>
           <a:prstGeom prst="rect">
             <a:avLst/>
@@ -8701,18 +9173,28 @@
               </a:defRPr>
             </a:pPr>
             <a:r>
+              <a:rPr sz="1200"/>
               <a:t>• PyCryptodome 3.19+ (crypto primitives)</a:t>
             </a:r>
-            <a:br/>
-            <a:r>
+            <a:br>
+              <a:rPr sz="1200"/>
+            </a:br>
+            <a:r>
+              <a:rPr sz="1200"/>
               <a:t>            • PyQt6 6.6+ (desktop UI framework)</a:t>
             </a:r>
-            <a:br/>
-            <a:r>
+            <a:br>
+              <a:rPr sz="1200"/>
+            </a:br>
+            <a:r>
+              <a:rPr sz="1200"/>
               <a:t>            • PyInstaller (standalone .exe build)</a:t>
             </a:r>
-            <a:br/>
-            <a:r>
+            <a:br>
+              <a:rPr sz="1200"/>
+            </a:br>
+            <a:r>
+              <a:rPr sz="1200"/>
               <a:t>            • Python 3.8+ standard library</a:t>
             </a:r>
           </a:p>
@@ -8727,7 +9209,7 @@
 </file>
 
 <file path=ppt/slides/slide7.xml><?xml version="1.0" encoding="utf-8"?>
-<p:sld xmlns:a="http://schemas.openxmlformats.org/drawingml/2006/main" xmlns:p="http://schemas.openxmlformats.org/presentationml/2006/main" xmlns:r="http://schemas.openxmlformats.org/officeDocument/2006/relationships">
+<p:sld xmlns:a="http://schemas.openxmlformats.org/drawingml/2006/main" xmlns:r="http://schemas.openxmlformats.org/officeDocument/2006/relationships" xmlns:p="http://schemas.openxmlformats.org/presentationml/2006/main">
   <p:cSld>
     <p:spTree>
       <p:nvGrpSpPr>
@@ -8735,7 +9217,14 @@
         <p:cNvGrpSpPr/>
         <p:nvPr/>
       </p:nvGrpSpPr>
-      <p:grpSpPr/>
+      <p:grpSpPr>
+        <a:xfrm>
+          <a:off x="0" y="0"/>
+          <a:ext cx="0" cy="0"/>
+          <a:chOff x="0" y="0"/>
+          <a:chExt cx="0" cy="0"/>
+        </a:xfrm>
+      </p:grpSpPr>
       <p:pic>
         <p:nvPicPr>
           <p:cNvPr id="2" name="Picture 1" descr="bg_1.png"/>
@@ -9032,21 +9521,21 @@
         </p:nvSpPr>
         <p:spPr>
           <a:xfrm>
-            <a:off x="761999" y="893117"/>
-            <a:ext cx="668982" cy="333375"/>
-          </a:xfrm>
-          <a:prstGeom prst="rect">
-            <a:avLst/>
-          </a:prstGeom>
-          <a:noFill/>
-        </p:spPr>
-        <p:txBody>
-          <a:bodyPr wrap="square" lIns="0" tIns="0" rIns="0" bIns="0">
-            <a:spAutoFit/>
-          </a:bodyPr>
-          <a:lstStyle/>
-          <a:p>
-            <a:pPr algn="l">
+            <a:off x="761999" y="946335"/>
+            <a:ext cx="668982" cy="138499"/>
+          </a:xfrm>
+          <a:prstGeom prst="rect">
+            <a:avLst/>
+          </a:prstGeom>
+          <a:noFill/>
+        </p:spPr>
+        <p:txBody>
+          <a:bodyPr wrap="square" lIns="0" tIns="0" rIns="0" bIns="0">
+            <a:spAutoFit/>
+          </a:bodyPr>
+          <a:lstStyle/>
+          <a:p>
+            <a:pPr algn="ctr">
               <a:defRPr sz="900" b="1">
                 <a:solidFill>
                   <a:srgbClr val="3FB950"/>
@@ -9054,6 +9543,7 @@
               </a:defRPr>
             </a:pPr>
             <a:r>
+              <a:rPr dirty="0"/>
               <a:t>DEMO</a:t>
             </a:r>
           </a:p>
@@ -9172,8 +9662,8 @@
         </p:nvSpPr>
         <p:spPr>
           <a:xfrm>
-            <a:off x="923924" y="3255317"/>
-            <a:ext cx="3105149" cy="984795"/>
+            <a:off x="1122286" y="3424684"/>
+            <a:ext cx="3105149" cy="484748"/>
           </a:xfrm>
           <a:prstGeom prst="rect">
             <a:avLst/>
@@ -9194,14 +9684,21 @@
               </a:defRPr>
             </a:pPr>
             <a:r>
+              <a:rPr sz="1050"/>
               <a:t>python cli.py keygen \</a:t>
             </a:r>
-            <a:br/>
-            <a:r>
+            <a:br>
+              <a:rPr sz="1050"/>
+            </a:br>
+            <a:r>
+              <a:rPr sz="1050"/>
               <a:t>  --private keys/private.pem \</a:t>
             </a:r>
-            <a:br/>
-            <a:r>
+            <a:br>
+              <a:rPr sz="1050"/>
+            </a:br>
+            <a:r>
+              <a:rPr sz="1050"/>
               <a:t>  --public  keys/public.pem</a:t>
             </a:r>
           </a:p>
@@ -9320,8 +9817,8 @@
         </p:nvSpPr>
         <p:spPr>
           <a:xfrm>
-            <a:off x="4543424" y="3255317"/>
-            <a:ext cx="3105149" cy="1173360"/>
+            <a:off x="4741786" y="3424684"/>
+            <a:ext cx="3105149" cy="646331"/>
           </a:xfrm>
           <a:prstGeom prst="rect">
             <a:avLst/>
@@ -9342,18 +9839,28 @@
               </a:defRPr>
             </a:pPr>
             <a:r>
+              <a:rPr sz="1050"/>
               <a:t>python cli.py encrypt \</a:t>
             </a:r>
-            <a:br/>
-            <a:r>
+            <a:br>
+              <a:rPr sz="1050"/>
+            </a:br>
+            <a:r>
+              <a:rPr sz="1050"/>
               <a:t>  --input  secret.txt \</a:t>
             </a:r>
-            <a:br/>
-            <a:r>
+            <a:br>
+              <a:rPr sz="1050"/>
+            </a:br>
+            <a:r>
+              <a:rPr sz="1050"/>
               <a:t>  --output secret.enc \</a:t>
             </a:r>
-            <a:br/>
-            <a:r>
+            <a:br>
+              <a:rPr sz="1050"/>
+            </a:br>
+            <a:r>
+              <a:rPr sz="1050"/>
               <a:t>  --key    keys/public.pem</a:t>
             </a:r>
           </a:p>
@@ -9472,8 +9979,8 @@
         </p:nvSpPr>
         <p:spPr>
           <a:xfrm>
-            <a:off x="8162924" y="3255317"/>
-            <a:ext cx="3105149" cy="1173360"/>
+            <a:off x="8361286" y="3424684"/>
+            <a:ext cx="3105149" cy="646331"/>
           </a:xfrm>
           <a:prstGeom prst="rect">
             <a:avLst/>
@@ -9494,18 +10001,28 @@
               </a:defRPr>
             </a:pPr>
             <a:r>
+              <a:rPr sz="1050"/>
               <a:t>python cli.py decrypt \</a:t>
             </a:r>
-            <a:br/>
-            <a:r>
+            <a:br>
+              <a:rPr sz="1050"/>
+            </a:br>
+            <a:r>
+              <a:rPr sz="1050"/>
               <a:t>  --input  secret.enc \</a:t>
             </a:r>
-            <a:br/>
-            <a:r>
+            <a:br>
+              <a:rPr sz="1050"/>
+            </a:br>
+            <a:r>
+              <a:rPr sz="1050"/>
               <a:t>  --output recovered.txt \</a:t>
             </a:r>
-            <a:br/>
-            <a:r>
+            <a:br>
+              <a:rPr sz="1050"/>
+            </a:br>
+            <a:r>
+              <a:rPr sz="1050"/>
               <a:t>  --key    keys/private.pem</a:t>
             </a:r>
           </a:p>
@@ -9555,7 +10072,7 @@
         <p:spPr>
           <a:xfrm>
             <a:off x="1038224" y="5483869"/>
-            <a:ext cx="10115549" cy="338137"/>
+            <a:ext cx="10115549" cy="215444"/>
           </a:xfrm>
           <a:prstGeom prst="rect">
             <a:avLst/>
@@ -9576,6 +10093,7 @@
               </a:defRPr>
             </a:pPr>
             <a:r>
+              <a:rPr sz="1400"/>
               <a:t>Flip bits in .enc file →  → Decryption aborted</a:t>
             </a:r>
           </a:p>
@@ -9590,7 +10108,7 @@
 </file>
 
 <file path=ppt/slides/slide8.xml><?xml version="1.0" encoding="utf-8"?>
-<p:sld xmlns:a="http://schemas.openxmlformats.org/drawingml/2006/main" xmlns:p="http://schemas.openxmlformats.org/presentationml/2006/main" xmlns:r="http://schemas.openxmlformats.org/officeDocument/2006/relationships">
+<p:sld xmlns:a="http://schemas.openxmlformats.org/drawingml/2006/main" xmlns:r="http://schemas.openxmlformats.org/officeDocument/2006/relationships" xmlns:p="http://schemas.openxmlformats.org/presentationml/2006/main">
   <p:cSld>
     <p:spTree>
       <p:nvGrpSpPr>
@@ -9598,7 +10116,14 @@
         <p:cNvGrpSpPr/>
         <p:nvPr/>
       </p:nvGrpSpPr>
-      <p:grpSpPr/>
+      <p:grpSpPr>
+        <a:xfrm>
+          <a:off x="0" y="0"/>
+          <a:ext cx="0" cy="0"/>
+          <a:chOff x="0" y="0"/>
+          <a:chExt cx="0" cy="0"/>
+        </a:xfrm>
+      </p:grpSpPr>
       <p:pic>
         <p:nvPicPr>
           <p:cNvPr id="2" name="Picture 1" descr="bg_1.png"/>
@@ -9751,21 +10276,21 @@
         </p:nvSpPr>
         <p:spPr>
           <a:xfrm>
-            <a:off x="761999" y="1338857"/>
-            <a:ext cx="937170" cy="333375"/>
-          </a:xfrm>
-          <a:prstGeom prst="rect">
-            <a:avLst/>
-          </a:prstGeom>
-          <a:noFill/>
-        </p:spPr>
-        <p:txBody>
-          <a:bodyPr wrap="square" lIns="0" tIns="0" rIns="0" bIns="0">
-            <a:spAutoFit/>
-          </a:bodyPr>
-          <a:lstStyle/>
-          <a:p>
-            <a:pPr algn="l">
+            <a:off x="761999" y="1392075"/>
+            <a:ext cx="937170" cy="138499"/>
+          </a:xfrm>
+          <a:prstGeom prst="rect">
+            <a:avLst/>
+          </a:prstGeom>
+          <a:noFill/>
+        </p:spPr>
+        <p:txBody>
+          <a:bodyPr wrap="square" lIns="0" tIns="0" rIns="0" bIns="0">
+            <a:spAutoFit/>
+          </a:bodyPr>
+          <a:lstStyle/>
+          <a:p>
+            <a:pPr algn="ctr">
               <a:defRPr sz="900" b="1">
                 <a:solidFill>
                   <a:srgbClr val="BC8CFF"/>
@@ -10066,21 +10591,21 @@
         </p:nvSpPr>
         <p:spPr>
           <a:xfrm>
-            <a:off x="6524624" y="3043832"/>
-            <a:ext cx="4629149" cy="624780"/>
-          </a:xfrm>
-          <a:prstGeom prst="rect">
-            <a:avLst/>
-          </a:prstGeom>
-          <a:noFill/>
-        </p:spPr>
-        <p:txBody>
-          <a:bodyPr wrap="square" lIns="0" tIns="0" rIns="0" bIns="0">
-            <a:spAutoFit/>
-          </a:bodyPr>
-          <a:lstStyle/>
-          <a:p>
-            <a:pPr algn="l">
+            <a:off x="6524624" y="3222838"/>
+            <a:ext cx="4629149" cy="184666"/>
+          </a:xfrm>
+          <a:prstGeom prst="rect">
+            <a:avLst/>
+          </a:prstGeom>
+          <a:noFill/>
+        </p:spPr>
+        <p:txBody>
+          <a:bodyPr wrap="square" lIns="0" tIns="0" rIns="0" bIns="0">
+            <a:spAutoFit/>
+          </a:bodyPr>
+          <a:lstStyle/>
+          <a:p>
+            <a:pPr algn="ctr">
               <a:defRPr sz="900">
                 <a:solidFill>
                   <a:srgbClr val="E6EDF3"/>
@@ -10088,6 +10613,7 @@
               </a:defRPr>
             </a:pPr>
             <a:r>
+              <a:rPr sz="1200"/>
               <a:t>dist\HybridCrypto.exe</a:t>
             </a:r>
           </a:p>
@@ -10207,7 +10733,7 @@
 </file>
 
 <file path=ppt/slides/slide9.xml><?xml version="1.0" encoding="utf-8"?>
-<p:sld xmlns:a="http://schemas.openxmlformats.org/drawingml/2006/main" xmlns:p="http://schemas.openxmlformats.org/presentationml/2006/main" xmlns:r="http://schemas.openxmlformats.org/officeDocument/2006/relationships">
+<p:sld xmlns:a="http://schemas.openxmlformats.org/drawingml/2006/main" xmlns:r="http://schemas.openxmlformats.org/officeDocument/2006/relationships" xmlns:p="http://schemas.openxmlformats.org/presentationml/2006/main">
   <p:cSld>
     <p:spTree>
       <p:nvGrpSpPr>
@@ -10215,7 +10741,14 @@
         <p:cNvGrpSpPr/>
         <p:nvPr/>
       </p:nvGrpSpPr>
-      <p:grpSpPr/>
+      <p:grpSpPr>
+        <a:xfrm>
+          <a:off x="0" y="0"/>
+          <a:ext cx="0" cy="0"/>
+          <a:chOff x="0" y="0"/>
+          <a:chExt cx="0" cy="0"/>
+        </a:xfrm>
+      </p:grpSpPr>
       <p:pic>
         <p:nvPicPr>
           <p:cNvPr id="2" name="Picture 1" descr="bg_1.png"/>
@@ -10232,7 +10765,7 @@
         </p:blipFill>
         <p:spPr>
           <a:xfrm>
-            <a:off x="0" y="0"/>
+            <a:off x="4838" y="0"/>
             <a:ext cx="12191999" cy="6858000"/>
           </a:xfrm>
           <a:prstGeom prst="rect">
@@ -10464,21 +10997,21 @@
         </p:nvSpPr>
         <p:spPr>
           <a:xfrm>
-            <a:off x="761999" y="895350"/>
-            <a:ext cx="858142" cy="333375"/>
-          </a:xfrm>
-          <a:prstGeom prst="rect">
-            <a:avLst/>
-          </a:prstGeom>
-          <a:noFill/>
-        </p:spPr>
-        <p:txBody>
-          <a:bodyPr wrap="square" lIns="0" tIns="0" rIns="0" bIns="0">
-            <a:spAutoFit/>
-          </a:bodyPr>
-          <a:lstStyle/>
-          <a:p>
-            <a:pPr algn="l">
+            <a:off x="761999" y="948568"/>
+            <a:ext cx="858142" cy="138499"/>
+          </a:xfrm>
+          <a:prstGeom prst="rect">
+            <a:avLst/>
+          </a:prstGeom>
+          <a:noFill/>
+        </p:spPr>
+        <p:txBody>
+          <a:bodyPr wrap="square" lIns="0" tIns="0" rIns="0" bIns="0">
+            <a:spAutoFit/>
+          </a:bodyPr>
+          <a:lstStyle/>
+          <a:p>
+            <a:pPr algn="ctr">
               <a:defRPr sz="900" b="1">
                 <a:solidFill>
                   <a:srgbClr val="3FB950"/>
@@ -10486,6 +11019,7 @@
               </a:defRPr>
             </a:pPr>
             <a:r>
+              <a:rPr dirty="0"/>
               <a:t>RESULTS</a:t>
             </a:r>
           </a:p>
@@ -10569,8 +11103,568 @@
         </p:nvSpPr>
         <p:spPr>
           <a:xfrm>
-            <a:off x="1038224" y="2676525"/>
-            <a:ext cx="3256359" cy="485775"/>
+            <a:off x="457198" y="2776708"/>
+            <a:ext cx="3256359" cy="161583"/>
+          </a:xfrm>
+          <a:prstGeom prst="rect">
+            <a:avLst/>
+          </a:prstGeom>
+          <a:noFill/>
+        </p:spPr>
+        <p:txBody>
+          <a:bodyPr wrap="square" lIns="0" tIns="0" rIns="0" bIns="0">
+            <a:spAutoFit/>
+          </a:bodyPr>
+          <a:lstStyle/>
+          <a:p>
+            <a:pPr algn="ctr">
+              <a:defRPr sz="1050" b="1">
+                <a:solidFill>
+                  <a:srgbClr val="58A6FF"/>
+                </a:solidFill>
+              </a:defRPr>
+            </a:pPr>
+            <a:r>
+              <a:t>Test Case</a:t>
+            </a:r>
+          </a:p>
+        </p:txBody>
+      </p:sp>
+      <p:sp>
+        <p:nvSpPr>
+          <p:cNvPr id="16" name="TextBox 15"/>
+          <p:cNvSpPr txBox="1"/>
+          <p:nvPr/>
+        </p:nvSpPr>
+        <p:spPr>
+          <a:xfrm>
+            <a:off x="3713558" y="2776708"/>
+            <a:ext cx="1372790" cy="161583"/>
+          </a:xfrm>
+          <a:prstGeom prst="rect">
+            <a:avLst/>
+          </a:prstGeom>
+          <a:noFill/>
+        </p:spPr>
+        <p:txBody>
+          <a:bodyPr wrap="square" lIns="0" tIns="0" rIns="0" bIns="0">
+            <a:spAutoFit/>
+          </a:bodyPr>
+          <a:lstStyle/>
+          <a:p>
+            <a:pPr algn="ctr">
+              <a:defRPr sz="1050" b="1">
+                <a:solidFill>
+                  <a:srgbClr val="58A6FF"/>
+                </a:solidFill>
+              </a:defRPr>
+            </a:pPr>
+            <a:r>
+              <a:t>Result</a:t>
+            </a:r>
+          </a:p>
+        </p:txBody>
+      </p:sp>
+      <p:sp>
+        <p:nvSpPr>
+          <p:cNvPr id="17" name="TextBox 16"/>
+          <p:cNvSpPr txBox="1"/>
+          <p:nvPr/>
+        </p:nvSpPr>
+        <p:spPr>
+          <a:xfrm>
+            <a:off x="457198" y="3167233"/>
+            <a:ext cx="3256359" cy="150041"/>
+          </a:xfrm>
+          <a:prstGeom prst="rect">
+            <a:avLst/>
+          </a:prstGeom>
+          <a:noFill/>
+        </p:spPr>
+        <p:txBody>
+          <a:bodyPr wrap="square" lIns="0" tIns="0" rIns="0" bIns="0">
+            <a:spAutoFit/>
+          </a:bodyPr>
+          <a:lstStyle/>
+          <a:p>
+            <a:pPr algn="ctr">
+              <a:defRPr sz="975">
+                <a:solidFill>
+                  <a:srgbClr val="F0F6FC"/>
+                </a:solidFill>
+              </a:defRPr>
+            </a:pPr>
+            <a:r>
+              <a:t>Empty file (0 bytes)</a:t>
+            </a:r>
+          </a:p>
+        </p:txBody>
+      </p:sp>
+      <p:sp>
+        <p:nvSpPr>
+          <p:cNvPr id="18" name="TextBox 17"/>
+          <p:cNvSpPr txBox="1"/>
+          <p:nvPr/>
+        </p:nvSpPr>
+        <p:spPr>
+          <a:xfrm>
+            <a:off x="3713558" y="3167233"/>
+            <a:ext cx="1372790" cy="150041"/>
+          </a:xfrm>
+          <a:prstGeom prst="rect">
+            <a:avLst/>
+          </a:prstGeom>
+          <a:noFill/>
+        </p:spPr>
+        <p:txBody>
+          <a:bodyPr wrap="square" lIns="0" tIns="0" rIns="0" bIns="0">
+            <a:spAutoFit/>
+          </a:bodyPr>
+          <a:lstStyle/>
+          <a:p>
+            <a:pPr algn="ctr">
+              <a:defRPr sz="975">
+                <a:solidFill>
+                  <a:srgbClr val="F0F6FC"/>
+                </a:solidFill>
+              </a:defRPr>
+            </a:pPr>
+            <a:r>
+              <a:t>PASS ✓</a:t>
+            </a:r>
+          </a:p>
+        </p:txBody>
+      </p:sp>
+      <p:sp>
+        <p:nvSpPr>
+          <p:cNvPr id="19" name="TextBox 18"/>
+          <p:cNvSpPr txBox="1"/>
+          <p:nvPr/>
+        </p:nvSpPr>
+        <p:spPr>
+          <a:xfrm>
+            <a:off x="457198" y="3543470"/>
+            <a:ext cx="3256359" cy="150041"/>
+          </a:xfrm>
+          <a:prstGeom prst="rect">
+            <a:avLst/>
+          </a:prstGeom>
+          <a:noFill/>
+        </p:spPr>
+        <p:txBody>
+          <a:bodyPr wrap="square" lIns="0" tIns="0" rIns="0" bIns="0">
+            <a:spAutoFit/>
+          </a:bodyPr>
+          <a:lstStyle/>
+          <a:p>
+            <a:pPr algn="ctr">
+              <a:defRPr sz="975">
+                <a:solidFill>
+                  <a:srgbClr val="F0F6FC"/>
+                </a:solidFill>
+              </a:defRPr>
+            </a:pPr>
+            <a:r>
+              <a:t>Small text (27 bytes)</a:t>
+            </a:r>
+          </a:p>
+        </p:txBody>
+      </p:sp>
+      <p:sp>
+        <p:nvSpPr>
+          <p:cNvPr id="20" name="TextBox 19"/>
+          <p:cNvSpPr txBox="1"/>
+          <p:nvPr/>
+        </p:nvSpPr>
+        <p:spPr>
+          <a:xfrm>
+            <a:off x="3713558" y="3543470"/>
+            <a:ext cx="1372790" cy="150041"/>
+          </a:xfrm>
+          <a:prstGeom prst="rect">
+            <a:avLst/>
+          </a:prstGeom>
+          <a:noFill/>
+        </p:spPr>
+        <p:txBody>
+          <a:bodyPr wrap="square" lIns="0" tIns="0" rIns="0" bIns="0">
+            <a:spAutoFit/>
+          </a:bodyPr>
+          <a:lstStyle/>
+          <a:p>
+            <a:pPr algn="ctr">
+              <a:defRPr sz="975">
+                <a:solidFill>
+                  <a:srgbClr val="F0F6FC"/>
+                </a:solidFill>
+              </a:defRPr>
+            </a:pPr>
+            <a:r>
+              <a:t>PASS ✓</a:t>
+            </a:r>
+          </a:p>
+        </p:txBody>
+      </p:sp>
+      <p:sp>
+        <p:nvSpPr>
+          <p:cNvPr id="21" name="TextBox 20"/>
+          <p:cNvSpPr txBox="1"/>
+          <p:nvPr/>
+        </p:nvSpPr>
+        <p:spPr>
+          <a:xfrm>
+            <a:off x="457198" y="3924470"/>
+            <a:ext cx="3256359" cy="150041"/>
+          </a:xfrm>
+          <a:prstGeom prst="rect">
+            <a:avLst/>
+          </a:prstGeom>
+          <a:noFill/>
+        </p:spPr>
+        <p:txBody>
+          <a:bodyPr wrap="square" lIns="0" tIns="0" rIns="0" bIns="0">
+            <a:spAutoFit/>
+          </a:bodyPr>
+          <a:lstStyle/>
+          <a:p>
+            <a:pPr algn="ctr">
+              <a:defRPr sz="975">
+                <a:solidFill>
+                  <a:srgbClr val="F0F6FC"/>
+                </a:solidFill>
+              </a:defRPr>
+            </a:pPr>
+            <a:r>
+              <a:t>Multiline text (440 bytes)</a:t>
+            </a:r>
+          </a:p>
+        </p:txBody>
+      </p:sp>
+      <p:sp>
+        <p:nvSpPr>
+          <p:cNvPr id="22" name="TextBox 21"/>
+          <p:cNvSpPr txBox="1"/>
+          <p:nvPr/>
+        </p:nvSpPr>
+        <p:spPr>
+          <a:xfrm>
+            <a:off x="3713558" y="3924470"/>
+            <a:ext cx="1372790" cy="150041"/>
+          </a:xfrm>
+          <a:prstGeom prst="rect">
+            <a:avLst/>
+          </a:prstGeom>
+          <a:noFill/>
+        </p:spPr>
+        <p:txBody>
+          <a:bodyPr wrap="square" lIns="0" tIns="0" rIns="0" bIns="0">
+            <a:spAutoFit/>
+          </a:bodyPr>
+          <a:lstStyle/>
+          <a:p>
+            <a:pPr algn="ctr">
+              <a:defRPr sz="975">
+                <a:solidFill>
+                  <a:srgbClr val="F0F6FC"/>
+                </a:solidFill>
+              </a:defRPr>
+            </a:pPr>
+            <a:r>
+              <a:t>PASS ✓</a:t>
+            </a:r>
+          </a:p>
+        </p:txBody>
+      </p:sp>
+      <p:sp>
+        <p:nvSpPr>
+          <p:cNvPr id="23" name="TextBox 22"/>
+          <p:cNvSpPr txBox="1"/>
+          <p:nvPr/>
+        </p:nvSpPr>
+        <p:spPr>
+          <a:xfrm>
+            <a:off x="457198" y="4305470"/>
+            <a:ext cx="3256359" cy="150041"/>
+          </a:xfrm>
+          <a:prstGeom prst="rect">
+            <a:avLst/>
+          </a:prstGeom>
+          <a:noFill/>
+        </p:spPr>
+        <p:txBody>
+          <a:bodyPr wrap="square" lIns="0" tIns="0" rIns="0" bIns="0">
+            <a:spAutoFit/>
+          </a:bodyPr>
+          <a:lstStyle/>
+          <a:p>
+            <a:pPr algn="ctr">
+              <a:defRPr sz="975">
+                <a:solidFill>
+                  <a:srgbClr val="F0F6FC"/>
+                </a:solidFill>
+              </a:defRPr>
+            </a:pPr>
+            <a:r>
+              <a:t>Binary data (4 KB)</a:t>
+            </a:r>
+          </a:p>
+        </p:txBody>
+      </p:sp>
+      <p:sp>
+        <p:nvSpPr>
+          <p:cNvPr id="24" name="TextBox 23"/>
+          <p:cNvSpPr txBox="1"/>
+          <p:nvPr/>
+        </p:nvSpPr>
+        <p:spPr>
+          <a:xfrm>
+            <a:off x="3713558" y="4305470"/>
+            <a:ext cx="1372790" cy="150041"/>
+          </a:xfrm>
+          <a:prstGeom prst="rect">
+            <a:avLst/>
+          </a:prstGeom>
+          <a:noFill/>
+        </p:spPr>
+        <p:txBody>
+          <a:bodyPr wrap="square" lIns="0" tIns="0" rIns="0" bIns="0">
+            <a:spAutoFit/>
+          </a:bodyPr>
+          <a:lstStyle/>
+          <a:p>
+            <a:pPr algn="ctr">
+              <a:defRPr sz="975">
+                <a:solidFill>
+                  <a:srgbClr val="F0F6FC"/>
+                </a:solidFill>
+              </a:defRPr>
+            </a:pPr>
+            <a:r>
+              <a:t>PASS ✓</a:t>
+            </a:r>
+          </a:p>
+        </p:txBody>
+      </p:sp>
+      <p:sp>
+        <p:nvSpPr>
+          <p:cNvPr id="25" name="TextBox 24"/>
+          <p:cNvSpPr txBox="1"/>
+          <p:nvPr/>
+        </p:nvSpPr>
+        <p:spPr>
+          <a:xfrm>
+            <a:off x="457198" y="4686470"/>
+            <a:ext cx="3256359" cy="150041"/>
+          </a:xfrm>
+          <a:prstGeom prst="rect">
+            <a:avLst/>
+          </a:prstGeom>
+          <a:noFill/>
+        </p:spPr>
+        <p:txBody>
+          <a:bodyPr wrap="square" lIns="0" tIns="0" rIns="0" bIns="0">
+            <a:spAutoFit/>
+          </a:bodyPr>
+          <a:lstStyle/>
+          <a:p>
+            <a:pPr algn="ctr">
+              <a:defRPr sz="975">
+                <a:solidFill>
+                  <a:srgbClr val="F0F6FC"/>
+                </a:solidFill>
+              </a:defRPr>
+            </a:pPr>
+            <a:r>
+              <a:t>Large file (512 KB)</a:t>
+            </a:r>
+          </a:p>
+        </p:txBody>
+      </p:sp>
+      <p:sp>
+        <p:nvSpPr>
+          <p:cNvPr id="26" name="TextBox 25"/>
+          <p:cNvSpPr txBox="1"/>
+          <p:nvPr/>
+        </p:nvSpPr>
+        <p:spPr>
+          <a:xfrm>
+            <a:off x="3713558" y="4686470"/>
+            <a:ext cx="1372790" cy="150041"/>
+          </a:xfrm>
+          <a:prstGeom prst="rect">
+            <a:avLst/>
+          </a:prstGeom>
+          <a:noFill/>
+        </p:spPr>
+        <p:txBody>
+          <a:bodyPr wrap="square" lIns="0" tIns="0" rIns="0" bIns="0">
+            <a:spAutoFit/>
+          </a:bodyPr>
+          <a:lstStyle/>
+          <a:p>
+            <a:pPr algn="ctr">
+              <a:defRPr sz="975">
+                <a:solidFill>
+                  <a:srgbClr val="F0F6FC"/>
+                </a:solidFill>
+              </a:defRPr>
+            </a:pPr>
+            <a:r>
+              <a:t>PASS ✓</a:t>
+            </a:r>
+          </a:p>
+        </p:txBody>
+      </p:sp>
+      <p:sp>
+        <p:nvSpPr>
+          <p:cNvPr id="27" name="TextBox 26"/>
+          <p:cNvSpPr txBox="1"/>
+          <p:nvPr/>
+        </p:nvSpPr>
+        <p:spPr>
+          <a:xfrm>
+            <a:off x="457198" y="5067470"/>
+            <a:ext cx="3256359" cy="150041"/>
+          </a:xfrm>
+          <a:prstGeom prst="rect">
+            <a:avLst/>
+          </a:prstGeom>
+          <a:noFill/>
+        </p:spPr>
+        <p:txBody>
+          <a:bodyPr wrap="square" lIns="0" tIns="0" rIns="0" bIns="0">
+            <a:spAutoFit/>
+          </a:bodyPr>
+          <a:lstStyle/>
+          <a:p>
+            <a:pPr algn="ctr">
+              <a:defRPr sz="975">
+                <a:solidFill>
+                  <a:srgbClr val="F0F6FC"/>
+                </a:solidFill>
+              </a:defRPr>
+            </a:pPr>
+            <a:r>
+              <a:t>Tamper detection</a:t>
+            </a:r>
+          </a:p>
+        </p:txBody>
+      </p:sp>
+      <p:sp>
+        <p:nvSpPr>
+          <p:cNvPr id="28" name="TextBox 27"/>
+          <p:cNvSpPr txBox="1"/>
+          <p:nvPr/>
+        </p:nvSpPr>
+        <p:spPr>
+          <a:xfrm>
+            <a:off x="3713558" y="5067470"/>
+            <a:ext cx="1372790" cy="150041"/>
+          </a:xfrm>
+          <a:prstGeom prst="rect">
+            <a:avLst/>
+          </a:prstGeom>
+          <a:noFill/>
+        </p:spPr>
+        <p:txBody>
+          <a:bodyPr wrap="square" lIns="0" tIns="0" rIns="0" bIns="0">
+            <a:spAutoFit/>
+          </a:bodyPr>
+          <a:lstStyle/>
+          <a:p>
+            <a:pPr algn="ctr">
+              <a:defRPr sz="975">
+                <a:solidFill>
+                  <a:srgbClr val="F0F6FC"/>
+                </a:solidFill>
+              </a:defRPr>
+            </a:pPr>
+            <a:r>
+              <a:t>PASS ✓</a:t>
+            </a:r>
+          </a:p>
+        </p:txBody>
+      </p:sp>
+      <p:sp>
+        <p:nvSpPr>
+          <p:cNvPr id="29" name="TextBox 28"/>
+          <p:cNvSpPr txBox="1"/>
+          <p:nvPr/>
+        </p:nvSpPr>
+        <p:spPr>
+          <a:xfrm>
+            <a:off x="457198" y="5448470"/>
+            <a:ext cx="3256359" cy="150041"/>
+          </a:xfrm>
+          <a:prstGeom prst="rect">
+            <a:avLst/>
+          </a:prstGeom>
+          <a:noFill/>
+        </p:spPr>
+        <p:txBody>
+          <a:bodyPr wrap="square" lIns="0" tIns="0" rIns="0" bIns="0">
+            <a:spAutoFit/>
+          </a:bodyPr>
+          <a:lstStyle/>
+          <a:p>
+            <a:pPr algn="ctr">
+              <a:defRPr sz="975">
+                <a:solidFill>
+                  <a:srgbClr val="F0F6FC"/>
+                </a:solidFill>
+              </a:defRPr>
+            </a:pPr>
+            <a:r>
+              <a:t>SHA-256 hash match</a:t>
+            </a:r>
+          </a:p>
+        </p:txBody>
+      </p:sp>
+      <p:sp>
+        <p:nvSpPr>
+          <p:cNvPr id="30" name="TextBox 29"/>
+          <p:cNvSpPr txBox="1"/>
+          <p:nvPr/>
+        </p:nvSpPr>
+        <p:spPr>
+          <a:xfrm>
+            <a:off x="3713558" y="5448470"/>
+            <a:ext cx="1372790" cy="150041"/>
+          </a:xfrm>
+          <a:prstGeom prst="rect">
+            <a:avLst/>
+          </a:prstGeom>
+          <a:noFill/>
+        </p:spPr>
+        <p:txBody>
+          <a:bodyPr wrap="square" lIns="0" tIns="0" rIns="0" bIns="0">
+            <a:spAutoFit/>
+          </a:bodyPr>
+          <a:lstStyle/>
+          <a:p>
+            <a:pPr algn="ctr">
+              <a:defRPr sz="975">
+                <a:solidFill>
+                  <a:srgbClr val="F0F6FC"/>
+                </a:solidFill>
+              </a:defRPr>
+            </a:pPr>
+            <a:r>
+              <a:t>PASS ✓</a:t>
+            </a:r>
+          </a:p>
+        </p:txBody>
+      </p:sp>
+      <p:sp>
+        <p:nvSpPr>
+          <p:cNvPr id="31" name="TextBox 30"/>
+          <p:cNvSpPr txBox="1"/>
+          <p:nvPr/>
+        </p:nvSpPr>
+        <p:spPr>
+          <a:xfrm>
+            <a:off x="6524624" y="2247900"/>
+            <a:ext cx="4629149" cy="371475"/>
           </a:xfrm>
           <a:prstGeom prst="rect">
             <a:avLst/>
@@ -10584,63 +11678,28 @@
           <a:lstStyle/>
           <a:p>
             <a:pPr algn="l">
-              <a:defRPr sz="1050" b="1">
-                <a:solidFill>
-                  <a:srgbClr val="58A6FF"/>
-                </a:solidFill>
-              </a:defRPr>
-            </a:pPr>
-            <a:r>
-              <a:t>Test Case</a:t>
-            </a:r>
-          </a:p>
-        </p:txBody>
-      </p:sp>
-      <p:sp>
-        <p:nvSpPr>
-          <p:cNvPr id="16" name="TextBox 15"/>
-          <p:cNvSpPr txBox="1"/>
-          <p:nvPr/>
-        </p:nvSpPr>
-        <p:spPr>
-          <a:xfrm>
-            <a:off x="4294584" y="2676525"/>
-            <a:ext cx="1372790" cy="485775"/>
-          </a:xfrm>
-          <a:prstGeom prst="rect">
-            <a:avLst/>
-          </a:prstGeom>
-          <a:noFill/>
-        </p:spPr>
-        <p:txBody>
-          <a:bodyPr wrap="square" lIns="0" tIns="0" rIns="0" bIns="0">
-            <a:spAutoFit/>
-          </a:bodyPr>
-          <a:lstStyle/>
-          <a:p>
-            <a:pPr algn="l">
-              <a:defRPr sz="1050" b="1">
-                <a:solidFill>
-                  <a:srgbClr val="58A6FF"/>
-                </a:solidFill>
-              </a:defRPr>
-            </a:pPr>
-            <a:r>
-              <a:t>Result</a:t>
-            </a:r>
-          </a:p>
-        </p:txBody>
-      </p:sp>
-      <p:sp>
-        <p:nvSpPr>
-          <p:cNvPr id="17" name="TextBox 16"/>
-          <p:cNvSpPr txBox="1"/>
-          <p:nvPr/>
-        </p:nvSpPr>
-        <p:spPr>
-          <a:xfrm>
-            <a:off x="1038224" y="3067050"/>
-            <a:ext cx="3256359" cy="471487"/>
+              <a:defRPr sz="1800" b="1">
+                <a:solidFill>
+                  <a:srgbClr val="E3B341"/>
+                </a:solidFill>
+              </a:defRPr>
+            </a:pPr>
+            <a:r>
+              <a:t>Performance</a:t>
+            </a:r>
+          </a:p>
+        </p:txBody>
+      </p:sp>
+      <p:sp>
+        <p:nvSpPr>
+          <p:cNvPr id="32" name="TextBox 31"/>
+          <p:cNvSpPr txBox="1"/>
+          <p:nvPr/>
+        </p:nvSpPr>
+        <p:spPr>
+          <a:xfrm>
+            <a:off x="6524624" y="2638425"/>
+            <a:ext cx="1535161" cy="247650"/>
           </a:xfrm>
           <a:prstGeom prst="rect">
             <a:avLst/>
@@ -10661,21 +11720,21 @@
               </a:defRPr>
             </a:pPr>
             <a:r>
-              <a:t>Empty file (0 bytes)</a:t>
-            </a:r>
-          </a:p>
-        </p:txBody>
-      </p:sp>
-      <p:sp>
-        <p:nvSpPr>
-          <p:cNvPr id="18" name="TextBox 17"/>
-          <p:cNvSpPr txBox="1"/>
-          <p:nvPr/>
-        </p:nvSpPr>
-        <p:spPr>
-          <a:xfrm>
-            <a:off x="4294584" y="3067050"/>
-            <a:ext cx="1372790" cy="471487"/>
+              <a:t>Key Generation (2048-bit)</a:t>
+            </a:r>
+          </a:p>
+        </p:txBody>
+      </p:sp>
+      <p:sp>
+        <p:nvSpPr>
+          <p:cNvPr id="33" name="TextBox 32"/>
+          <p:cNvSpPr txBox="1"/>
+          <p:nvPr/>
+        </p:nvSpPr>
+        <p:spPr>
+          <a:xfrm>
+            <a:off x="10824119" y="2638425"/>
+            <a:ext cx="329654" cy="247650"/>
           </a:xfrm>
           <a:prstGeom prst="rect">
             <a:avLst/>
@@ -10691,26 +11750,26 @@
             <a:pPr algn="l">
               <a:defRPr sz="975">
                 <a:solidFill>
-                  <a:srgbClr val="F0F6FC"/>
-                </a:solidFill>
-              </a:defRPr>
-            </a:pPr>
-            <a:r>
-              <a:t>PASS ✓</a:t>
-            </a:r>
-          </a:p>
-        </p:txBody>
-      </p:sp>
-      <p:sp>
-        <p:nvSpPr>
-          <p:cNvPr id="19" name="TextBox 18"/>
-          <p:cNvSpPr txBox="1"/>
-          <p:nvPr/>
-        </p:nvSpPr>
-        <p:spPr>
-          <a:xfrm>
-            <a:off x="1038224" y="3443287"/>
-            <a:ext cx="3256359" cy="476250"/>
+                  <a:srgbClr val="58A6FF"/>
+                </a:solidFill>
+              </a:defRPr>
+            </a:pPr>
+            <a:r>
+              <a:t>~0.5s</a:t>
+            </a:r>
+          </a:p>
+        </p:txBody>
+      </p:sp>
+      <p:sp>
+        <p:nvSpPr>
+          <p:cNvPr id="34" name="TextBox 33"/>
+          <p:cNvSpPr txBox="1"/>
+          <p:nvPr/>
+        </p:nvSpPr>
+        <p:spPr>
+          <a:xfrm>
+            <a:off x="6524624" y="3057525"/>
+            <a:ext cx="1153715" cy="247650"/>
           </a:xfrm>
           <a:prstGeom prst="rect">
             <a:avLst/>
@@ -10731,21 +11790,21 @@
               </a:defRPr>
             </a:pPr>
             <a:r>
-              <a:t>Small text (27 bytes)</a:t>
-            </a:r>
-          </a:p>
-        </p:txBody>
-      </p:sp>
-      <p:sp>
-        <p:nvSpPr>
-          <p:cNvPr id="20" name="TextBox 19"/>
-          <p:cNvSpPr txBox="1"/>
-          <p:nvPr/>
-        </p:nvSpPr>
-        <p:spPr>
-          <a:xfrm>
-            <a:off x="4294584" y="3443287"/>
-            <a:ext cx="1372790" cy="476250"/>
+              <a:t>1 MB file encryption</a:t>
+            </a:r>
+          </a:p>
+        </p:txBody>
+      </p:sp>
+      <p:sp>
+        <p:nvSpPr>
+          <p:cNvPr id="35" name="TextBox 34"/>
+          <p:cNvSpPr txBox="1"/>
+          <p:nvPr/>
+        </p:nvSpPr>
+        <p:spPr>
+          <a:xfrm>
+            <a:off x="10856117" y="3057525"/>
+            <a:ext cx="297656" cy="247650"/>
           </a:xfrm>
           <a:prstGeom prst="rect">
             <a:avLst/>
@@ -10761,26 +11820,26 @@
             <a:pPr algn="l">
               <a:defRPr sz="975">
                 <a:solidFill>
-                  <a:srgbClr val="F0F6FC"/>
-                </a:solidFill>
-              </a:defRPr>
-            </a:pPr>
-            <a:r>
-              <a:t>PASS ✓</a:t>
-            </a:r>
-          </a:p>
-        </p:txBody>
-      </p:sp>
-      <p:sp>
-        <p:nvSpPr>
-          <p:cNvPr id="21" name="TextBox 20"/>
-          <p:cNvSpPr txBox="1"/>
-          <p:nvPr/>
-        </p:nvSpPr>
-        <p:spPr>
-          <a:xfrm>
-            <a:off x="1038224" y="3824287"/>
-            <a:ext cx="3256359" cy="476250"/>
+                  <a:srgbClr val="3FB950"/>
+                </a:solidFill>
+              </a:defRPr>
+            </a:pPr>
+            <a:r>
+              <a:t>&lt;0.1s</a:t>
+            </a:r>
+          </a:p>
+        </p:txBody>
+      </p:sp>
+      <p:sp>
+        <p:nvSpPr>
+          <p:cNvPr id="36" name="TextBox 35"/>
+          <p:cNvSpPr txBox="1"/>
+          <p:nvPr/>
+        </p:nvSpPr>
+        <p:spPr>
+          <a:xfrm>
+            <a:off x="6524624" y="3476625"/>
+            <a:ext cx="1156394" cy="247650"/>
           </a:xfrm>
           <a:prstGeom prst="rect">
             <a:avLst/>
@@ -10801,21 +11860,21 @@
               </a:defRPr>
             </a:pPr>
             <a:r>
-              <a:t>Multiline text (440 bytes)</a:t>
-            </a:r>
-          </a:p>
-        </p:txBody>
-      </p:sp>
-      <p:sp>
-        <p:nvSpPr>
-          <p:cNvPr id="22" name="TextBox 21"/>
-          <p:cNvSpPr txBox="1"/>
-          <p:nvPr/>
-        </p:nvSpPr>
-        <p:spPr>
-          <a:xfrm>
-            <a:off x="4294584" y="3824287"/>
-            <a:ext cx="1372790" cy="476250"/>
+              <a:t>1 MB file decryption</a:t>
+            </a:r>
+          </a:p>
+        </p:txBody>
+      </p:sp>
+      <p:sp>
+        <p:nvSpPr>
+          <p:cNvPr id="37" name="TextBox 36"/>
+          <p:cNvSpPr txBox="1"/>
+          <p:nvPr/>
+        </p:nvSpPr>
+        <p:spPr>
+          <a:xfrm>
+            <a:off x="10856117" y="3476625"/>
+            <a:ext cx="297656" cy="247650"/>
           </a:xfrm>
           <a:prstGeom prst="rect">
             <a:avLst/>
@@ -10831,26 +11890,26 @@
             <a:pPr algn="l">
               <a:defRPr sz="975">
                 <a:solidFill>
-                  <a:srgbClr val="F0F6FC"/>
-                </a:solidFill>
-              </a:defRPr>
-            </a:pPr>
-            <a:r>
-              <a:t>PASS ✓</a:t>
-            </a:r>
-          </a:p>
-        </p:txBody>
-      </p:sp>
-      <p:sp>
-        <p:nvSpPr>
-          <p:cNvPr id="23" name="TextBox 22"/>
-          <p:cNvSpPr txBox="1"/>
-          <p:nvPr/>
-        </p:nvSpPr>
-        <p:spPr>
-          <a:xfrm>
-            <a:off x="1038224" y="4205287"/>
-            <a:ext cx="3256359" cy="476250"/>
+                  <a:srgbClr val="3FB950"/>
+                </a:solidFill>
+              </a:defRPr>
+            </a:pPr>
+            <a:r>
+              <a:t>&lt;0.1s</a:t>
+            </a:r>
+          </a:p>
+        </p:txBody>
+      </p:sp>
+      <p:sp>
+        <p:nvSpPr>
+          <p:cNvPr id="38" name="TextBox 37"/>
+          <p:cNvSpPr txBox="1"/>
+          <p:nvPr/>
+        </p:nvSpPr>
+        <p:spPr>
+          <a:xfrm>
+            <a:off x="6524624" y="3895725"/>
+            <a:ext cx="1309985" cy="247650"/>
           </a:xfrm>
           <a:prstGeom prst="rect">
             <a:avLst/>
@@ -10871,21 +11930,21 @@
               </a:defRPr>
             </a:pPr>
             <a:r>
-              <a:t>Binary data (4 KB)</a:t>
-            </a:r>
-          </a:p>
-        </p:txBody>
-      </p:sp>
-      <p:sp>
-        <p:nvSpPr>
-          <p:cNvPr id="24" name="TextBox 23"/>
-          <p:cNvSpPr txBox="1"/>
-          <p:nvPr/>
-        </p:nvSpPr>
-        <p:spPr>
-          <a:xfrm>
-            <a:off x="4294584" y="4205287"/>
-            <a:ext cx="1372790" cy="476250"/>
+              <a:t>100 MB file encryption</a:t>
+            </a:r>
+          </a:p>
+        </p:txBody>
+      </p:sp>
+      <p:sp>
+        <p:nvSpPr>
+          <p:cNvPr id="39" name="TextBox 38"/>
+          <p:cNvSpPr txBox="1"/>
+          <p:nvPr/>
+        </p:nvSpPr>
+        <p:spPr>
+          <a:xfrm>
+            <a:off x="10826798" y="3895725"/>
+            <a:ext cx="326975" cy="247650"/>
           </a:xfrm>
           <a:prstGeom prst="rect">
             <a:avLst/>
@@ -10901,26 +11960,26 @@
             <a:pPr algn="l">
               <a:defRPr sz="975">
                 <a:solidFill>
-                  <a:srgbClr val="F0F6FC"/>
-                </a:solidFill>
-              </a:defRPr>
-            </a:pPr>
-            <a:r>
-              <a:t>PASS ✓</a:t>
-            </a:r>
-          </a:p>
-        </p:txBody>
-      </p:sp>
-      <p:sp>
-        <p:nvSpPr>
-          <p:cNvPr id="25" name="TextBox 24"/>
-          <p:cNvSpPr txBox="1"/>
-          <p:nvPr/>
-        </p:nvSpPr>
-        <p:spPr>
-          <a:xfrm>
-            <a:off x="1038224" y="4586287"/>
-            <a:ext cx="3256359" cy="476250"/>
+                  <a:srgbClr val="E3B341"/>
+                </a:solidFill>
+              </a:defRPr>
+            </a:pPr>
+            <a:r>
+              <a:t>~3.5s</a:t>
+            </a:r>
+          </a:p>
+        </p:txBody>
+      </p:sp>
+      <p:sp>
+        <p:nvSpPr>
+          <p:cNvPr id="40" name="TextBox 39"/>
+          <p:cNvSpPr txBox="1"/>
+          <p:nvPr/>
+        </p:nvSpPr>
+        <p:spPr>
+          <a:xfrm>
+            <a:off x="6524624" y="4943475"/>
+            <a:ext cx="4629149" cy="553998"/>
           </a:xfrm>
           <a:prstGeom prst="rect">
             <a:avLst/>
@@ -10936,544 +11995,26 @@
             <a:pPr algn="l">
               <a:defRPr sz="975">
                 <a:solidFill>
-                  <a:srgbClr val="F0F6FC"/>
-                </a:solidFill>
-              </a:defRPr>
-            </a:pPr>
-            <a:r>
-              <a:t>Large file (512 KB)</a:t>
-            </a:r>
-          </a:p>
-        </p:txBody>
-      </p:sp>
-      <p:sp>
-        <p:nvSpPr>
-          <p:cNvPr id="26" name="TextBox 25"/>
-          <p:cNvSpPr txBox="1"/>
-          <p:nvPr/>
-        </p:nvSpPr>
-        <p:spPr>
-          <a:xfrm>
-            <a:off x="4294584" y="4586287"/>
-            <a:ext cx="1372790" cy="476250"/>
-          </a:xfrm>
-          <a:prstGeom prst="rect">
-            <a:avLst/>
-          </a:prstGeom>
-          <a:noFill/>
-        </p:spPr>
-        <p:txBody>
-          <a:bodyPr wrap="square" lIns="0" tIns="0" rIns="0" bIns="0">
-            <a:spAutoFit/>
-          </a:bodyPr>
-          <a:lstStyle/>
-          <a:p>
-            <a:pPr algn="l">
-              <a:defRPr sz="975">
-                <a:solidFill>
-                  <a:srgbClr val="F0F6FC"/>
-                </a:solidFill>
-              </a:defRPr>
-            </a:pPr>
-            <a:r>
-              <a:t>PASS ✓</a:t>
-            </a:r>
-          </a:p>
-        </p:txBody>
-      </p:sp>
-      <p:sp>
-        <p:nvSpPr>
-          <p:cNvPr id="27" name="TextBox 26"/>
-          <p:cNvSpPr txBox="1"/>
-          <p:nvPr/>
-        </p:nvSpPr>
-        <p:spPr>
-          <a:xfrm>
-            <a:off x="1038224" y="4967287"/>
-            <a:ext cx="3256359" cy="476250"/>
-          </a:xfrm>
-          <a:prstGeom prst="rect">
-            <a:avLst/>
-          </a:prstGeom>
-          <a:noFill/>
-        </p:spPr>
-        <p:txBody>
-          <a:bodyPr wrap="square" lIns="0" tIns="0" rIns="0" bIns="0">
-            <a:spAutoFit/>
-          </a:bodyPr>
-          <a:lstStyle/>
-          <a:p>
-            <a:pPr algn="l">
-              <a:defRPr sz="975">
-                <a:solidFill>
-                  <a:srgbClr val="F0F6FC"/>
-                </a:solidFill>
-              </a:defRPr>
-            </a:pPr>
-            <a:r>
-              <a:t>Tamper detection</a:t>
-            </a:r>
-          </a:p>
-        </p:txBody>
-      </p:sp>
-      <p:sp>
-        <p:nvSpPr>
-          <p:cNvPr id="28" name="TextBox 27"/>
-          <p:cNvSpPr txBox="1"/>
-          <p:nvPr/>
-        </p:nvSpPr>
-        <p:spPr>
-          <a:xfrm>
-            <a:off x="4294584" y="4967287"/>
-            <a:ext cx="1372790" cy="476250"/>
-          </a:xfrm>
-          <a:prstGeom prst="rect">
-            <a:avLst/>
-          </a:prstGeom>
-          <a:noFill/>
-        </p:spPr>
-        <p:txBody>
-          <a:bodyPr wrap="square" lIns="0" tIns="0" rIns="0" bIns="0">
-            <a:spAutoFit/>
-          </a:bodyPr>
-          <a:lstStyle/>
-          <a:p>
-            <a:pPr algn="l">
-              <a:defRPr sz="975">
-                <a:solidFill>
-                  <a:srgbClr val="F0F6FC"/>
-                </a:solidFill>
-              </a:defRPr>
-            </a:pPr>
-            <a:r>
-              <a:t>PASS ✓</a:t>
-            </a:r>
-          </a:p>
-        </p:txBody>
-      </p:sp>
-      <p:sp>
-        <p:nvSpPr>
-          <p:cNvPr id="29" name="TextBox 28"/>
-          <p:cNvSpPr txBox="1"/>
-          <p:nvPr/>
-        </p:nvSpPr>
-        <p:spPr>
-          <a:xfrm>
-            <a:off x="1038224" y="5348287"/>
-            <a:ext cx="3256359" cy="471487"/>
-          </a:xfrm>
-          <a:prstGeom prst="rect">
-            <a:avLst/>
-          </a:prstGeom>
-          <a:noFill/>
-        </p:spPr>
-        <p:txBody>
-          <a:bodyPr wrap="square" lIns="0" tIns="0" rIns="0" bIns="0">
-            <a:spAutoFit/>
-          </a:bodyPr>
-          <a:lstStyle/>
-          <a:p>
-            <a:pPr algn="l">
-              <a:defRPr sz="975">
-                <a:solidFill>
-                  <a:srgbClr val="F0F6FC"/>
-                </a:solidFill>
-              </a:defRPr>
-            </a:pPr>
-            <a:r>
-              <a:t>SHA-256 hash match</a:t>
-            </a:r>
-          </a:p>
-        </p:txBody>
-      </p:sp>
-      <p:sp>
-        <p:nvSpPr>
-          <p:cNvPr id="30" name="TextBox 29"/>
-          <p:cNvSpPr txBox="1"/>
-          <p:nvPr/>
-        </p:nvSpPr>
-        <p:spPr>
-          <a:xfrm>
-            <a:off x="4294584" y="5348287"/>
-            <a:ext cx="1372790" cy="471487"/>
-          </a:xfrm>
-          <a:prstGeom prst="rect">
-            <a:avLst/>
-          </a:prstGeom>
-          <a:noFill/>
-        </p:spPr>
-        <p:txBody>
-          <a:bodyPr wrap="square" lIns="0" tIns="0" rIns="0" bIns="0">
-            <a:spAutoFit/>
-          </a:bodyPr>
-          <a:lstStyle/>
-          <a:p>
-            <a:pPr algn="l">
-              <a:defRPr sz="975">
-                <a:solidFill>
-                  <a:srgbClr val="F0F6FC"/>
-                </a:solidFill>
-              </a:defRPr>
-            </a:pPr>
-            <a:r>
-              <a:t>PASS ✓</a:t>
-            </a:r>
-          </a:p>
-        </p:txBody>
-      </p:sp>
-      <p:sp>
-        <p:nvSpPr>
-          <p:cNvPr id="31" name="TextBox 30"/>
-          <p:cNvSpPr txBox="1"/>
-          <p:nvPr/>
-        </p:nvSpPr>
-        <p:spPr>
-          <a:xfrm>
-            <a:off x="6524624" y="2247900"/>
-            <a:ext cx="4629149" cy="371475"/>
-          </a:xfrm>
-          <a:prstGeom prst="rect">
-            <a:avLst/>
-          </a:prstGeom>
-          <a:noFill/>
-        </p:spPr>
-        <p:txBody>
-          <a:bodyPr wrap="square" lIns="0" tIns="0" rIns="0" bIns="0">
-            <a:spAutoFit/>
-          </a:bodyPr>
-          <a:lstStyle/>
-          <a:p>
-            <a:pPr algn="l">
-              <a:defRPr sz="1800" b="1">
-                <a:solidFill>
-                  <a:srgbClr val="E3B341"/>
-                </a:solidFill>
-              </a:defRPr>
-            </a:pPr>
-            <a:r>
-              <a:t>Performance</a:t>
-            </a:r>
-          </a:p>
-        </p:txBody>
-      </p:sp>
-      <p:sp>
-        <p:nvSpPr>
-          <p:cNvPr id="32" name="TextBox 31"/>
-          <p:cNvSpPr txBox="1"/>
-          <p:nvPr/>
-        </p:nvSpPr>
-        <p:spPr>
-          <a:xfrm>
-            <a:off x="6524624" y="2638425"/>
-            <a:ext cx="1535161" cy="247650"/>
-          </a:xfrm>
-          <a:prstGeom prst="rect">
-            <a:avLst/>
-          </a:prstGeom>
-          <a:noFill/>
-        </p:spPr>
-        <p:txBody>
-          <a:bodyPr wrap="square" lIns="0" tIns="0" rIns="0" bIns="0">
-            <a:spAutoFit/>
-          </a:bodyPr>
-          <a:lstStyle/>
-          <a:p>
-            <a:pPr algn="l">
-              <a:defRPr sz="975">
-                <a:solidFill>
-                  <a:srgbClr val="F0F6FC"/>
-                </a:solidFill>
-              </a:defRPr>
-            </a:pPr>
-            <a:r>
-              <a:t>Key Generation (2048-bit)</a:t>
-            </a:r>
-          </a:p>
-        </p:txBody>
-      </p:sp>
-      <p:sp>
-        <p:nvSpPr>
-          <p:cNvPr id="33" name="TextBox 32"/>
-          <p:cNvSpPr txBox="1"/>
-          <p:nvPr/>
-        </p:nvSpPr>
-        <p:spPr>
-          <a:xfrm>
-            <a:off x="10824119" y="2638425"/>
-            <a:ext cx="329654" cy="247650"/>
-          </a:xfrm>
-          <a:prstGeom prst="rect">
-            <a:avLst/>
-          </a:prstGeom>
-          <a:noFill/>
-        </p:spPr>
-        <p:txBody>
-          <a:bodyPr wrap="square" lIns="0" tIns="0" rIns="0" bIns="0">
-            <a:spAutoFit/>
-          </a:bodyPr>
-          <a:lstStyle/>
-          <a:p>
-            <a:pPr algn="l">
-              <a:defRPr sz="975">
-                <a:solidFill>
-                  <a:srgbClr val="58A6FF"/>
-                </a:solidFill>
-              </a:defRPr>
-            </a:pPr>
-            <a:r>
-              <a:t>~0.5s</a:t>
-            </a:r>
-          </a:p>
-        </p:txBody>
-      </p:sp>
-      <p:sp>
-        <p:nvSpPr>
-          <p:cNvPr id="34" name="TextBox 33"/>
-          <p:cNvSpPr txBox="1"/>
-          <p:nvPr/>
-        </p:nvSpPr>
-        <p:spPr>
-          <a:xfrm>
-            <a:off x="6524624" y="3057525"/>
-            <a:ext cx="1153715" cy="247650"/>
-          </a:xfrm>
-          <a:prstGeom prst="rect">
-            <a:avLst/>
-          </a:prstGeom>
-          <a:noFill/>
-        </p:spPr>
-        <p:txBody>
-          <a:bodyPr wrap="square" lIns="0" tIns="0" rIns="0" bIns="0">
-            <a:spAutoFit/>
-          </a:bodyPr>
-          <a:lstStyle/>
-          <a:p>
-            <a:pPr algn="l">
-              <a:defRPr sz="975">
-                <a:solidFill>
-                  <a:srgbClr val="F0F6FC"/>
-                </a:solidFill>
-              </a:defRPr>
-            </a:pPr>
-            <a:r>
-              <a:t>1 MB file encryption</a:t>
-            </a:r>
-          </a:p>
-        </p:txBody>
-      </p:sp>
-      <p:sp>
-        <p:nvSpPr>
-          <p:cNvPr id="35" name="TextBox 34"/>
-          <p:cNvSpPr txBox="1"/>
-          <p:nvPr/>
-        </p:nvSpPr>
-        <p:spPr>
-          <a:xfrm>
-            <a:off x="10856117" y="3057525"/>
-            <a:ext cx="297656" cy="247650"/>
-          </a:xfrm>
-          <a:prstGeom prst="rect">
-            <a:avLst/>
-          </a:prstGeom>
-          <a:noFill/>
-        </p:spPr>
-        <p:txBody>
-          <a:bodyPr wrap="square" lIns="0" tIns="0" rIns="0" bIns="0">
-            <a:spAutoFit/>
-          </a:bodyPr>
-          <a:lstStyle/>
-          <a:p>
-            <a:pPr algn="l">
-              <a:defRPr sz="975">
-                <a:solidFill>
-                  <a:srgbClr val="3FB950"/>
-                </a:solidFill>
-              </a:defRPr>
-            </a:pPr>
-            <a:r>
-              <a:t>&lt;0.1s</a:t>
-            </a:r>
-          </a:p>
-        </p:txBody>
-      </p:sp>
-      <p:sp>
-        <p:nvSpPr>
-          <p:cNvPr id="36" name="TextBox 35"/>
-          <p:cNvSpPr txBox="1"/>
-          <p:nvPr/>
-        </p:nvSpPr>
-        <p:spPr>
-          <a:xfrm>
-            <a:off x="6524624" y="3476625"/>
-            <a:ext cx="1156394" cy="247650"/>
-          </a:xfrm>
-          <a:prstGeom prst="rect">
-            <a:avLst/>
-          </a:prstGeom>
-          <a:noFill/>
-        </p:spPr>
-        <p:txBody>
-          <a:bodyPr wrap="square" lIns="0" tIns="0" rIns="0" bIns="0">
-            <a:spAutoFit/>
-          </a:bodyPr>
-          <a:lstStyle/>
-          <a:p>
-            <a:pPr algn="l">
-              <a:defRPr sz="975">
-                <a:solidFill>
-                  <a:srgbClr val="F0F6FC"/>
-                </a:solidFill>
-              </a:defRPr>
-            </a:pPr>
-            <a:r>
-              <a:t>1 MB file decryption</a:t>
-            </a:r>
-          </a:p>
-        </p:txBody>
-      </p:sp>
-      <p:sp>
-        <p:nvSpPr>
-          <p:cNvPr id="37" name="TextBox 36"/>
-          <p:cNvSpPr txBox="1"/>
-          <p:nvPr/>
-        </p:nvSpPr>
-        <p:spPr>
-          <a:xfrm>
-            <a:off x="10856117" y="3476625"/>
-            <a:ext cx="297656" cy="247650"/>
-          </a:xfrm>
-          <a:prstGeom prst="rect">
-            <a:avLst/>
-          </a:prstGeom>
-          <a:noFill/>
-        </p:spPr>
-        <p:txBody>
-          <a:bodyPr wrap="square" lIns="0" tIns="0" rIns="0" bIns="0">
-            <a:spAutoFit/>
-          </a:bodyPr>
-          <a:lstStyle/>
-          <a:p>
-            <a:pPr algn="l">
-              <a:defRPr sz="975">
-                <a:solidFill>
-                  <a:srgbClr val="3FB950"/>
-                </a:solidFill>
-              </a:defRPr>
-            </a:pPr>
-            <a:r>
-              <a:t>&lt;0.1s</a:t>
-            </a:r>
-          </a:p>
-        </p:txBody>
-      </p:sp>
-      <p:sp>
-        <p:nvSpPr>
-          <p:cNvPr id="38" name="TextBox 37"/>
-          <p:cNvSpPr txBox="1"/>
-          <p:nvPr/>
-        </p:nvSpPr>
-        <p:spPr>
-          <a:xfrm>
-            <a:off x="6524624" y="3895725"/>
-            <a:ext cx="1309985" cy="247650"/>
-          </a:xfrm>
-          <a:prstGeom prst="rect">
-            <a:avLst/>
-          </a:prstGeom>
-          <a:noFill/>
-        </p:spPr>
-        <p:txBody>
-          <a:bodyPr wrap="square" lIns="0" tIns="0" rIns="0" bIns="0">
-            <a:spAutoFit/>
-          </a:bodyPr>
-          <a:lstStyle/>
-          <a:p>
-            <a:pPr algn="l">
-              <a:defRPr sz="975">
-                <a:solidFill>
-                  <a:srgbClr val="F0F6FC"/>
-                </a:solidFill>
-              </a:defRPr>
-            </a:pPr>
-            <a:r>
-              <a:t>100 MB file encryption</a:t>
-            </a:r>
-          </a:p>
-        </p:txBody>
-      </p:sp>
-      <p:sp>
-        <p:nvSpPr>
-          <p:cNvPr id="39" name="TextBox 38"/>
-          <p:cNvSpPr txBox="1"/>
-          <p:nvPr/>
-        </p:nvSpPr>
-        <p:spPr>
-          <a:xfrm>
-            <a:off x="10826798" y="3895725"/>
-            <a:ext cx="326975" cy="247650"/>
-          </a:xfrm>
-          <a:prstGeom prst="rect">
-            <a:avLst/>
-          </a:prstGeom>
-          <a:noFill/>
-        </p:spPr>
-        <p:txBody>
-          <a:bodyPr wrap="square" lIns="0" tIns="0" rIns="0" bIns="0">
-            <a:spAutoFit/>
-          </a:bodyPr>
-          <a:lstStyle/>
-          <a:p>
-            <a:pPr algn="l">
-              <a:defRPr sz="975">
-                <a:solidFill>
-                  <a:srgbClr val="E3B341"/>
-                </a:solidFill>
-              </a:defRPr>
-            </a:pPr>
-            <a:r>
-              <a:t>~3.5s</a:t>
-            </a:r>
-          </a:p>
-        </p:txBody>
-      </p:sp>
-      <p:sp>
-        <p:nvSpPr>
-          <p:cNvPr id="40" name="TextBox 39"/>
-          <p:cNvSpPr txBox="1"/>
-          <p:nvPr/>
-        </p:nvSpPr>
-        <p:spPr>
-          <a:xfrm>
-            <a:off x="6524624" y="4943475"/>
-            <a:ext cx="4629149" cy="763637"/>
-          </a:xfrm>
-          <a:prstGeom prst="rect">
-            <a:avLst/>
-          </a:prstGeom>
-          <a:noFill/>
-        </p:spPr>
-        <p:txBody>
-          <a:bodyPr wrap="square" lIns="0" tIns="0" rIns="0" bIns="0">
-            <a:spAutoFit/>
-          </a:bodyPr>
-          <a:lstStyle/>
-          <a:p>
-            <a:pPr algn="l">
-              <a:defRPr sz="975">
-                <a:solidFill>
                   <a:srgbClr val="8B949E"/>
                 </a:solidFill>
               </a:defRPr>
             </a:pPr>
             <a:r>
+              <a:rPr sz="1200"/>
               <a:t>✓ SHA-256 hashes match before/after in  test cases</a:t>
             </a:r>
-            <a:br/>
-            <a:r>
+            <a:br>
+              <a:rPr sz="1200"/>
+            </a:br>
+            <a:r>
+              <a:rPr sz="1200"/>
               <a:t>            ✓ All  pass (0 failures)</a:t>
             </a:r>
-            <a:br/>
-            <a:r>
+            <a:br>
+              <a:rPr sz="1200"/>
+            </a:br>
+            <a:r>
+              <a:rPr sz="1200"/>
               <a:t>            ✓ Supports text, binary, PDF, image files</a:t>
             </a:r>
           </a:p>

</xml_diff>